<commit_message>
Update for W18 DA Metricas de negocio
</commit_message>
<xml_diff>
--- a/07-herramientas-desarrollo/14-git.pptx
+++ b/07-herramientas-desarrollo/14-git.pptx
@@ -15,7 +15,7 @@
     <p:sldId id="262" r:id="rId10"/>
   </p:sldIdLst>
   <p:sldSz cx="9144000" cy="5143500"/>
-  <p:notesSz cx="6858000" cy="9144000"/>
+  <p:notesSz cx="7772400" cy="10058400"/>
 </p:presentation>
 </file>
 
@@ -50,7 +50,7 @@
         <p:txBody>
           <a:bodyPr/>
           <a:p>
-            <a:fld id="{534A192A-B628-42AB-AF1E-09773FE53E3E}" type="slidenum">
+            <a:fld id="{52139788-0820-43E5-90AC-38F921DB00C5}" type="slidenum">
               <a:t>&lt;#&gt;</a:t>
             </a:fld>
           </a:p>
@@ -106,10 +106,10 @@
             <a:noAutofit/>
           </a:bodyPr>
           <a:p>
-            <a:pPr indent="0">
-              <a:buNone/>
-            </a:pPr>
-            <a:endParaRPr b="0" lang="es-MX" sz="1400" spc="-1" strike="noStrike">
+            <a:pPr indent="0" algn="ctr">
+              <a:buNone/>
+            </a:pPr>
+            <a:endParaRPr b="0" lang="es-MX" sz="4400" spc="-1" strike="noStrike">
               <a:solidFill>
                 <a:srgbClr val="000000"/>
               </a:solidFill>
@@ -152,7 +152,7 @@
               </a:spcBef>
               <a:buNone/>
             </a:pPr>
-            <a:endParaRPr b="0" lang="es-MX" sz="1400" spc="-1" strike="noStrike">
+            <a:endParaRPr b="0" lang="es-MX" sz="3200" spc="-1" strike="noStrike">
               <a:solidFill>
                 <a:srgbClr val="000000"/>
               </a:solidFill>
@@ -195,7 +195,7 @@
               </a:spcBef>
               <a:buNone/>
             </a:pPr>
-            <a:endParaRPr b="0" lang="es-MX" sz="1400" spc="-1" strike="noStrike">
+            <a:endParaRPr b="0" lang="es-MX" sz="3200" spc="-1" strike="noStrike">
               <a:solidFill>
                 <a:srgbClr val="000000"/>
               </a:solidFill>
@@ -218,7 +218,7 @@
         <p:txBody>
           <a:bodyPr/>
           <a:p>
-            <a:fld id="{F2736DB3-41A7-4C51-80C8-15B299261193}" type="slidenum">
+            <a:fld id="{CD5387F5-DC33-4920-8797-A7F5DD2E0ACA}" type="slidenum">
               <a:t>&lt;#&gt;</a:t>
             </a:fld>
           </a:p>
@@ -274,10 +274,10 @@
             <a:noAutofit/>
           </a:bodyPr>
           <a:p>
-            <a:pPr indent="0">
-              <a:buNone/>
-            </a:pPr>
-            <a:endParaRPr b="0" lang="es-MX" sz="1400" spc="-1" strike="noStrike">
+            <a:pPr indent="0" algn="ctr">
+              <a:buNone/>
+            </a:pPr>
+            <a:endParaRPr b="0" lang="es-MX" sz="4400" spc="-1" strike="noStrike">
               <a:solidFill>
                 <a:srgbClr val="000000"/>
               </a:solidFill>
@@ -320,7 +320,7 @@
               </a:spcBef>
               <a:buNone/>
             </a:pPr>
-            <a:endParaRPr b="0" lang="es-MX" sz="1400" spc="-1" strike="noStrike">
+            <a:endParaRPr b="0" lang="es-MX" sz="3200" spc="-1" strike="noStrike">
               <a:solidFill>
                 <a:srgbClr val="000000"/>
               </a:solidFill>
@@ -363,7 +363,7 @@
               </a:spcBef>
               <a:buNone/>
             </a:pPr>
-            <a:endParaRPr b="0" lang="es-MX" sz="1400" spc="-1" strike="noStrike">
+            <a:endParaRPr b="0" lang="es-MX" sz="3200" spc="-1" strike="noStrike">
               <a:solidFill>
                 <a:srgbClr val="000000"/>
               </a:solidFill>
@@ -406,7 +406,7 @@
               </a:spcBef>
               <a:buNone/>
             </a:pPr>
-            <a:endParaRPr b="0" lang="es-MX" sz="1400" spc="-1" strike="noStrike">
+            <a:endParaRPr b="0" lang="es-MX" sz="3200" spc="-1" strike="noStrike">
               <a:solidFill>
                 <a:srgbClr val="000000"/>
               </a:solidFill>
@@ -449,7 +449,7 @@
               </a:spcBef>
               <a:buNone/>
             </a:pPr>
-            <a:endParaRPr b="0" lang="es-MX" sz="1400" spc="-1" strike="noStrike">
+            <a:endParaRPr b="0" lang="es-MX" sz="3200" spc="-1" strike="noStrike">
               <a:solidFill>
                 <a:srgbClr val="000000"/>
               </a:solidFill>
@@ -472,7 +472,7 @@
         <p:txBody>
           <a:bodyPr/>
           <a:p>
-            <a:fld id="{04EB7BBB-5516-41FD-BA50-92E34E93818A}" type="slidenum">
+            <a:fld id="{C7D926CA-7CF8-410F-8665-6630DDBC83D2}" type="slidenum">
               <a:t>&lt;#&gt;</a:t>
             </a:fld>
           </a:p>
@@ -528,10 +528,10 @@
             <a:noAutofit/>
           </a:bodyPr>
           <a:p>
-            <a:pPr indent="0">
-              <a:buNone/>
-            </a:pPr>
-            <a:endParaRPr b="0" lang="es-MX" sz="1400" spc="-1" strike="noStrike">
+            <a:pPr indent="0" algn="ctr">
+              <a:buNone/>
+            </a:pPr>
+            <a:endParaRPr b="0" lang="es-MX" sz="4400" spc="-1" strike="noStrike">
               <a:solidFill>
                 <a:srgbClr val="000000"/>
               </a:solidFill>
@@ -574,7 +574,7 @@
               </a:spcBef>
               <a:buNone/>
             </a:pPr>
-            <a:endParaRPr b="0" lang="es-MX" sz="1400" spc="-1" strike="noStrike">
+            <a:endParaRPr b="0" lang="es-MX" sz="3200" spc="-1" strike="noStrike">
               <a:solidFill>
                 <a:srgbClr val="000000"/>
               </a:solidFill>
@@ -617,7 +617,7 @@
               </a:spcBef>
               <a:buNone/>
             </a:pPr>
-            <a:endParaRPr b="0" lang="es-MX" sz="1400" spc="-1" strike="noStrike">
+            <a:endParaRPr b="0" lang="es-MX" sz="3200" spc="-1" strike="noStrike">
               <a:solidFill>
                 <a:srgbClr val="000000"/>
               </a:solidFill>
@@ -660,7 +660,7 @@
               </a:spcBef>
               <a:buNone/>
             </a:pPr>
-            <a:endParaRPr b="0" lang="es-MX" sz="1400" spc="-1" strike="noStrike">
+            <a:endParaRPr b="0" lang="es-MX" sz="3200" spc="-1" strike="noStrike">
               <a:solidFill>
                 <a:srgbClr val="000000"/>
               </a:solidFill>
@@ -703,7 +703,7 @@
               </a:spcBef>
               <a:buNone/>
             </a:pPr>
-            <a:endParaRPr b="0" lang="es-MX" sz="1400" spc="-1" strike="noStrike">
+            <a:endParaRPr b="0" lang="es-MX" sz="3200" spc="-1" strike="noStrike">
               <a:solidFill>
                 <a:srgbClr val="000000"/>
               </a:solidFill>
@@ -746,7 +746,7 @@
               </a:spcBef>
               <a:buNone/>
             </a:pPr>
-            <a:endParaRPr b="0" lang="es-MX" sz="1400" spc="-1" strike="noStrike">
+            <a:endParaRPr b="0" lang="es-MX" sz="3200" spc="-1" strike="noStrike">
               <a:solidFill>
                 <a:srgbClr val="000000"/>
               </a:solidFill>
@@ -789,7 +789,7 @@
               </a:spcBef>
               <a:buNone/>
             </a:pPr>
-            <a:endParaRPr b="0" lang="es-MX" sz="1400" spc="-1" strike="noStrike">
+            <a:endParaRPr b="0" lang="es-MX" sz="3200" spc="-1" strike="noStrike">
               <a:solidFill>
                 <a:srgbClr val="000000"/>
               </a:solidFill>
@@ -812,7 +812,7 @@
         <p:txBody>
           <a:bodyPr/>
           <a:p>
-            <a:fld id="{0248F76D-354B-49F8-878E-AD685269261B}" type="slidenum">
+            <a:fld id="{25D35878-4A41-492F-8180-3BEF593DAB8B}" type="slidenum">
               <a:t>&lt;#&gt;</a:t>
             </a:fld>
           </a:p>
@@ -854,7 +854,7 @@
         <p:txBody>
           <a:bodyPr/>
           <a:p>
-            <a:fld id="{9F299BFD-B4BB-457F-88E5-92BAFCF03D47}" type="slidenum">
+            <a:fld id="{62463B25-DD8E-4FA8-9084-295899C06FF0}" type="slidenum">
               <a:t>&lt;#&gt;</a:t>
             </a:fld>
           </a:p>
@@ -910,10 +910,10 @@
             <a:noAutofit/>
           </a:bodyPr>
           <a:p>
-            <a:pPr indent="0">
-              <a:buNone/>
-            </a:pPr>
-            <a:endParaRPr b="0" lang="es-MX" sz="1400" spc="-1" strike="noStrike">
+            <a:pPr indent="0" algn="ctr">
+              <a:buNone/>
+            </a:pPr>
+            <a:endParaRPr b="0" lang="es-MX" sz="4400" spc="-1" strike="noStrike">
               <a:solidFill>
                 <a:srgbClr val="000000"/>
               </a:solidFill>
@@ -976,7 +976,7 @@
         <p:txBody>
           <a:bodyPr/>
           <a:p>
-            <a:fld id="{4BF69A19-19D7-4664-A821-FC16537A658B}" type="slidenum">
+            <a:fld id="{34E13E23-DE2C-49A2-85F4-776913D1355F}" type="slidenum">
               <a:t>&lt;#&gt;</a:t>
             </a:fld>
           </a:p>
@@ -1032,10 +1032,10 @@
             <a:noAutofit/>
           </a:bodyPr>
           <a:p>
-            <a:pPr indent="0">
-              <a:buNone/>
-            </a:pPr>
-            <a:endParaRPr b="0" lang="es-MX" sz="1400" spc="-1" strike="noStrike">
+            <a:pPr indent="0" algn="ctr">
+              <a:buNone/>
+            </a:pPr>
+            <a:endParaRPr b="0" lang="es-MX" sz="4400" spc="-1" strike="noStrike">
               <a:solidFill>
                 <a:srgbClr val="000000"/>
               </a:solidFill>
@@ -1078,7 +1078,7 @@
               </a:spcBef>
               <a:buNone/>
             </a:pPr>
-            <a:endParaRPr b="0" lang="es-MX" sz="1400" spc="-1" strike="noStrike">
+            <a:endParaRPr b="0" lang="es-MX" sz="3200" spc="-1" strike="noStrike">
               <a:solidFill>
                 <a:srgbClr val="000000"/>
               </a:solidFill>
@@ -1101,7 +1101,7 @@
         <p:txBody>
           <a:bodyPr/>
           <a:p>
-            <a:fld id="{AA674D27-EDB7-4E61-9EC9-82366B89B3A8}" type="slidenum">
+            <a:fld id="{000F8ED2-A26D-4D9F-B34A-2C5DD8AAA4E9}" type="slidenum">
               <a:t>&lt;#&gt;</a:t>
             </a:fld>
           </a:p>
@@ -1157,10 +1157,10 @@
             <a:noAutofit/>
           </a:bodyPr>
           <a:p>
-            <a:pPr indent="0">
-              <a:buNone/>
-            </a:pPr>
-            <a:endParaRPr b="0" lang="es-MX" sz="1400" spc="-1" strike="noStrike">
+            <a:pPr indent="0" algn="ctr">
+              <a:buNone/>
+            </a:pPr>
+            <a:endParaRPr b="0" lang="es-MX" sz="4400" spc="-1" strike="noStrike">
               <a:solidFill>
                 <a:srgbClr val="000000"/>
               </a:solidFill>
@@ -1203,7 +1203,7 @@
               </a:spcBef>
               <a:buNone/>
             </a:pPr>
-            <a:endParaRPr b="0" lang="es-MX" sz="1400" spc="-1" strike="noStrike">
+            <a:endParaRPr b="0" lang="es-MX" sz="3200" spc="-1" strike="noStrike">
               <a:solidFill>
                 <a:srgbClr val="000000"/>
               </a:solidFill>
@@ -1246,7 +1246,7 @@
               </a:spcBef>
               <a:buNone/>
             </a:pPr>
-            <a:endParaRPr b="0" lang="es-MX" sz="1400" spc="-1" strike="noStrike">
+            <a:endParaRPr b="0" lang="es-MX" sz="3200" spc="-1" strike="noStrike">
               <a:solidFill>
                 <a:srgbClr val="000000"/>
               </a:solidFill>
@@ -1269,7 +1269,7 @@
         <p:txBody>
           <a:bodyPr/>
           <a:p>
-            <a:fld id="{EDF7ED8C-6BC6-4E1D-9526-38CE807383D5}" type="slidenum">
+            <a:fld id="{92DCE6E1-CFD8-4A27-A576-A014F907A813}" type="slidenum">
               <a:t>&lt;#&gt;</a:t>
             </a:fld>
           </a:p>
@@ -1325,10 +1325,10 @@
             <a:noAutofit/>
           </a:bodyPr>
           <a:p>
-            <a:pPr indent="0">
-              <a:buNone/>
-            </a:pPr>
-            <a:endParaRPr b="0" lang="es-MX" sz="1400" spc="-1" strike="noStrike">
+            <a:pPr indent="0" algn="ctr">
+              <a:buNone/>
+            </a:pPr>
+            <a:endParaRPr b="0" lang="es-MX" sz="4400" spc="-1" strike="noStrike">
               <a:solidFill>
                 <a:srgbClr val="000000"/>
               </a:solidFill>
@@ -1351,7 +1351,7 @@
         <p:txBody>
           <a:bodyPr/>
           <a:p>
-            <a:fld id="{FCE4D802-5E45-4180-87E6-6A768AE7EEFE}" type="slidenum">
+            <a:fld id="{9960679A-B609-4EDF-BF9A-5126733072AD}" type="slidenum">
               <a:t>&lt;#&gt;</a:t>
             </a:fld>
           </a:p>
@@ -1431,7 +1431,7 @@
         <p:txBody>
           <a:bodyPr/>
           <a:p>
-            <a:fld id="{84619581-D179-487D-B65F-D8AB2A4781DF}" type="slidenum">
+            <a:fld id="{83583EAA-F8D5-4D29-94E1-8262A3904874}" type="slidenum">
               <a:t>&lt;#&gt;</a:t>
             </a:fld>
           </a:p>
@@ -1487,10 +1487,10 @@
             <a:noAutofit/>
           </a:bodyPr>
           <a:p>
-            <a:pPr indent="0">
-              <a:buNone/>
-            </a:pPr>
-            <a:endParaRPr b="0" lang="es-MX" sz="1400" spc="-1" strike="noStrike">
+            <a:pPr indent="0" algn="ctr">
+              <a:buNone/>
+            </a:pPr>
+            <a:endParaRPr b="0" lang="es-MX" sz="4400" spc="-1" strike="noStrike">
               <a:solidFill>
                 <a:srgbClr val="000000"/>
               </a:solidFill>
@@ -1533,7 +1533,7 @@
               </a:spcBef>
               <a:buNone/>
             </a:pPr>
-            <a:endParaRPr b="0" lang="es-MX" sz="1400" spc="-1" strike="noStrike">
+            <a:endParaRPr b="0" lang="es-MX" sz="3200" spc="-1" strike="noStrike">
               <a:solidFill>
                 <a:srgbClr val="000000"/>
               </a:solidFill>
@@ -1576,7 +1576,7 @@
               </a:spcBef>
               <a:buNone/>
             </a:pPr>
-            <a:endParaRPr b="0" lang="es-MX" sz="1400" spc="-1" strike="noStrike">
+            <a:endParaRPr b="0" lang="es-MX" sz="3200" spc="-1" strike="noStrike">
               <a:solidFill>
                 <a:srgbClr val="000000"/>
               </a:solidFill>
@@ -1619,7 +1619,7 @@
               </a:spcBef>
               <a:buNone/>
             </a:pPr>
-            <a:endParaRPr b="0" lang="es-MX" sz="1400" spc="-1" strike="noStrike">
+            <a:endParaRPr b="0" lang="es-MX" sz="3200" spc="-1" strike="noStrike">
               <a:solidFill>
                 <a:srgbClr val="000000"/>
               </a:solidFill>
@@ -1642,7 +1642,7 @@
         <p:txBody>
           <a:bodyPr/>
           <a:p>
-            <a:fld id="{B4A640B9-8ACC-4FDE-B6A6-399B45BBF7A0}" type="slidenum">
+            <a:fld id="{84575AD2-E6A1-4FFD-A63F-F9A1AFBF9EA3}" type="slidenum">
               <a:t>&lt;#&gt;</a:t>
             </a:fld>
           </a:p>
@@ -1698,10 +1698,10 @@
             <a:noAutofit/>
           </a:bodyPr>
           <a:p>
-            <a:pPr indent="0">
-              <a:buNone/>
-            </a:pPr>
-            <a:endParaRPr b="0" lang="es-MX" sz="1400" spc="-1" strike="noStrike">
+            <a:pPr indent="0" algn="ctr">
+              <a:buNone/>
+            </a:pPr>
+            <a:endParaRPr b="0" lang="es-MX" sz="4400" spc="-1" strike="noStrike">
               <a:solidFill>
                 <a:srgbClr val="000000"/>
               </a:solidFill>
@@ -1764,7 +1764,7 @@
         <p:txBody>
           <a:bodyPr/>
           <a:p>
-            <a:fld id="{D1FB79B9-663B-40FA-A8EF-1CAFF5B96607}" type="slidenum">
+            <a:fld id="{1B817EF8-0D7A-424E-8FB6-476EA10FB107}" type="slidenum">
               <a:t>&lt;#&gt;</a:t>
             </a:fld>
           </a:p>
@@ -1820,10 +1820,10 @@
             <a:noAutofit/>
           </a:bodyPr>
           <a:p>
-            <a:pPr indent="0">
-              <a:buNone/>
-            </a:pPr>
-            <a:endParaRPr b="0" lang="es-MX" sz="1400" spc="-1" strike="noStrike">
+            <a:pPr indent="0" algn="ctr">
+              <a:buNone/>
+            </a:pPr>
+            <a:endParaRPr b="0" lang="es-MX" sz="4400" spc="-1" strike="noStrike">
               <a:solidFill>
                 <a:srgbClr val="000000"/>
               </a:solidFill>
@@ -1866,7 +1866,7 @@
               </a:spcBef>
               <a:buNone/>
             </a:pPr>
-            <a:endParaRPr b="0" lang="es-MX" sz="1400" spc="-1" strike="noStrike">
+            <a:endParaRPr b="0" lang="es-MX" sz="3200" spc="-1" strike="noStrike">
               <a:solidFill>
                 <a:srgbClr val="000000"/>
               </a:solidFill>
@@ -1909,7 +1909,7 @@
               </a:spcBef>
               <a:buNone/>
             </a:pPr>
-            <a:endParaRPr b="0" lang="es-MX" sz="1400" spc="-1" strike="noStrike">
+            <a:endParaRPr b="0" lang="es-MX" sz="3200" spc="-1" strike="noStrike">
               <a:solidFill>
                 <a:srgbClr val="000000"/>
               </a:solidFill>
@@ -1952,7 +1952,7 @@
               </a:spcBef>
               <a:buNone/>
             </a:pPr>
-            <a:endParaRPr b="0" lang="es-MX" sz="1400" spc="-1" strike="noStrike">
+            <a:endParaRPr b="0" lang="es-MX" sz="3200" spc="-1" strike="noStrike">
               <a:solidFill>
                 <a:srgbClr val="000000"/>
               </a:solidFill>
@@ -1975,7 +1975,7 @@
         <p:txBody>
           <a:bodyPr/>
           <a:p>
-            <a:fld id="{1C71DED9-9AD1-4F2D-9E3D-D92E9C8FCB0D}" type="slidenum">
+            <a:fld id="{E29187CA-A10C-4647-AB05-AC5FFB8908BE}" type="slidenum">
               <a:t>&lt;#&gt;</a:t>
             </a:fld>
           </a:p>
@@ -2031,10 +2031,10 @@
             <a:noAutofit/>
           </a:bodyPr>
           <a:p>
-            <a:pPr indent="0">
-              <a:buNone/>
-            </a:pPr>
-            <a:endParaRPr b="0" lang="es-MX" sz="1400" spc="-1" strike="noStrike">
+            <a:pPr indent="0" algn="ctr">
+              <a:buNone/>
+            </a:pPr>
+            <a:endParaRPr b="0" lang="es-MX" sz="4400" spc="-1" strike="noStrike">
               <a:solidFill>
                 <a:srgbClr val="000000"/>
               </a:solidFill>
@@ -2077,7 +2077,7 @@
               </a:spcBef>
               <a:buNone/>
             </a:pPr>
-            <a:endParaRPr b="0" lang="es-MX" sz="1400" spc="-1" strike="noStrike">
+            <a:endParaRPr b="0" lang="es-MX" sz="3200" spc="-1" strike="noStrike">
               <a:solidFill>
                 <a:srgbClr val="000000"/>
               </a:solidFill>
@@ -2120,7 +2120,7 @@
               </a:spcBef>
               <a:buNone/>
             </a:pPr>
-            <a:endParaRPr b="0" lang="es-MX" sz="1400" spc="-1" strike="noStrike">
+            <a:endParaRPr b="0" lang="es-MX" sz="3200" spc="-1" strike="noStrike">
               <a:solidFill>
                 <a:srgbClr val="000000"/>
               </a:solidFill>
@@ -2163,7 +2163,7 @@
               </a:spcBef>
               <a:buNone/>
             </a:pPr>
-            <a:endParaRPr b="0" lang="es-MX" sz="1400" spc="-1" strike="noStrike">
+            <a:endParaRPr b="0" lang="es-MX" sz="3200" spc="-1" strike="noStrike">
               <a:solidFill>
                 <a:srgbClr val="000000"/>
               </a:solidFill>
@@ -2186,7 +2186,7 @@
         <p:txBody>
           <a:bodyPr/>
           <a:p>
-            <a:fld id="{E891A779-1BA4-4F3C-8D61-C07693F8F934}" type="slidenum">
+            <a:fld id="{A29D8777-552D-4A63-A8E9-A37B9709E4D9}" type="slidenum">
               <a:t>&lt;#&gt;</a:t>
             </a:fld>
           </a:p>
@@ -2242,10 +2242,10 @@
             <a:noAutofit/>
           </a:bodyPr>
           <a:p>
-            <a:pPr indent="0">
-              <a:buNone/>
-            </a:pPr>
-            <a:endParaRPr b="0" lang="es-MX" sz="1400" spc="-1" strike="noStrike">
+            <a:pPr indent="0" algn="ctr">
+              <a:buNone/>
+            </a:pPr>
+            <a:endParaRPr b="0" lang="es-MX" sz="4400" spc="-1" strike="noStrike">
               <a:solidFill>
                 <a:srgbClr val="000000"/>
               </a:solidFill>
@@ -2288,7 +2288,7 @@
               </a:spcBef>
               <a:buNone/>
             </a:pPr>
-            <a:endParaRPr b="0" lang="es-MX" sz="1400" spc="-1" strike="noStrike">
+            <a:endParaRPr b="0" lang="es-MX" sz="3200" spc="-1" strike="noStrike">
               <a:solidFill>
                 <a:srgbClr val="000000"/>
               </a:solidFill>
@@ -2331,7 +2331,7 @@
               </a:spcBef>
               <a:buNone/>
             </a:pPr>
-            <a:endParaRPr b="0" lang="es-MX" sz="1400" spc="-1" strike="noStrike">
+            <a:endParaRPr b="0" lang="es-MX" sz="3200" spc="-1" strike="noStrike">
               <a:solidFill>
                 <a:srgbClr val="000000"/>
               </a:solidFill>
@@ -2354,7 +2354,7 @@
         <p:txBody>
           <a:bodyPr/>
           <a:p>
-            <a:fld id="{E404BCD0-9476-42D3-8A66-0FCFC42C87C1}" type="slidenum">
+            <a:fld id="{C438441B-A119-4F31-8054-8D71884C7A15}" type="slidenum">
               <a:t>&lt;#&gt;</a:t>
             </a:fld>
           </a:p>
@@ -2410,10 +2410,10 @@
             <a:noAutofit/>
           </a:bodyPr>
           <a:p>
-            <a:pPr indent="0">
-              <a:buNone/>
-            </a:pPr>
-            <a:endParaRPr b="0" lang="es-MX" sz="1400" spc="-1" strike="noStrike">
+            <a:pPr indent="0" algn="ctr">
+              <a:buNone/>
+            </a:pPr>
+            <a:endParaRPr b="0" lang="es-MX" sz="4400" spc="-1" strike="noStrike">
               <a:solidFill>
                 <a:srgbClr val="000000"/>
               </a:solidFill>
@@ -2456,7 +2456,7 @@
               </a:spcBef>
               <a:buNone/>
             </a:pPr>
-            <a:endParaRPr b="0" lang="es-MX" sz="1400" spc="-1" strike="noStrike">
+            <a:endParaRPr b="0" lang="es-MX" sz="3200" spc="-1" strike="noStrike">
               <a:solidFill>
                 <a:srgbClr val="000000"/>
               </a:solidFill>
@@ -2499,7 +2499,7 @@
               </a:spcBef>
               <a:buNone/>
             </a:pPr>
-            <a:endParaRPr b="0" lang="es-MX" sz="1400" spc="-1" strike="noStrike">
+            <a:endParaRPr b="0" lang="es-MX" sz="3200" spc="-1" strike="noStrike">
               <a:solidFill>
                 <a:srgbClr val="000000"/>
               </a:solidFill>
@@ -2542,7 +2542,7 @@
               </a:spcBef>
               <a:buNone/>
             </a:pPr>
-            <a:endParaRPr b="0" lang="es-MX" sz="1400" spc="-1" strike="noStrike">
+            <a:endParaRPr b="0" lang="es-MX" sz="3200" spc="-1" strike="noStrike">
               <a:solidFill>
                 <a:srgbClr val="000000"/>
               </a:solidFill>
@@ -2585,7 +2585,7 @@
               </a:spcBef>
               <a:buNone/>
             </a:pPr>
-            <a:endParaRPr b="0" lang="es-MX" sz="1400" spc="-1" strike="noStrike">
+            <a:endParaRPr b="0" lang="es-MX" sz="3200" spc="-1" strike="noStrike">
               <a:solidFill>
                 <a:srgbClr val="000000"/>
               </a:solidFill>
@@ -2608,7 +2608,7 @@
         <p:txBody>
           <a:bodyPr/>
           <a:p>
-            <a:fld id="{0F22C2D8-55ED-40A2-B898-48CBABE4ACF8}" type="slidenum">
+            <a:fld id="{39731254-F2F5-4F2C-8DCC-6562F1F4B0B0}" type="slidenum">
               <a:t>&lt;#&gt;</a:t>
             </a:fld>
           </a:p>
@@ -2664,10 +2664,10 @@
             <a:noAutofit/>
           </a:bodyPr>
           <a:p>
-            <a:pPr indent="0">
-              <a:buNone/>
-            </a:pPr>
-            <a:endParaRPr b="0" lang="es-MX" sz="1400" spc="-1" strike="noStrike">
+            <a:pPr indent="0" algn="ctr">
+              <a:buNone/>
+            </a:pPr>
+            <a:endParaRPr b="0" lang="es-MX" sz="4400" spc="-1" strike="noStrike">
               <a:solidFill>
                 <a:srgbClr val="000000"/>
               </a:solidFill>
@@ -2710,7 +2710,7 @@
               </a:spcBef>
               <a:buNone/>
             </a:pPr>
-            <a:endParaRPr b="0" lang="es-MX" sz="1400" spc="-1" strike="noStrike">
+            <a:endParaRPr b="0" lang="es-MX" sz="3200" spc="-1" strike="noStrike">
               <a:solidFill>
                 <a:srgbClr val="000000"/>
               </a:solidFill>
@@ -2753,7 +2753,7 @@
               </a:spcBef>
               <a:buNone/>
             </a:pPr>
-            <a:endParaRPr b="0" lang="es-MX" sz="1400" spc="-1" strike="noStrike">
+            <a:endParaRPr b="0" lang="es-MX" sz="3200" spc="-1" strike="noStrike">
               <a:solidFill>
                 <a:srgbClr val="000000"/>
               </a:solidFill>
@@ -2796,7 +2796,7 @@
               </a:spcBef>
               <a:buNone/>
             </a:pPr>
-            <a:endParaRPr b="0" lang="es-MX" sz="1400" spc="-1" strike="noStrike">
+            <a:endParaRPr b="0" lang="es-MX" sz="3200" spc="-1" strike="noStrike">
               <a:solidFill>
                 <a:srgbClr val="000000"/>
               </a:solidFill>
@@ -2839,7 +2839,7 @@
               </a:spcBef>
               <a:buNone/>
             </a:pPr>
-            <a:endParaRPr b="0" lang="es-MX" sz="1400" spc="-1" strike="noStrike">
+            <a:endParaRPr b="0" lang="es-MX" sz="3200" spc="-1" strike="noStrike">
               <a:solidFill>
                 <a:srgbClr val="000000"/>
               </a:solidFill>
@@ -2882,7 +2882,7 @@
               </a:spcBef>
               <a:buNone/>
             </a:pPr>
-            <a:endParaRPr b="0" lang="es-MX" sz="1400" spc="-1" strike="noStrike">
+            <a:endParaRPr b="0" lang="es-MX" sz="3200" spc="-1" strike="noStrike">
               <a:solidFill>
                 <a:srgbClr val="000000"/>
               </a:solidFill>
@@ -2925,7 +2925,7 @@
               </a:spcBef>
               <a:buNone/>
             </a:pPr>
-            <a:endParaRPr b="0" lang="es-MX" sz="1400" spc="-1" strike="noStrike">
+            <a:endParaRPr b="0" lang="es-MX" sz="3200" spc="-1" strike="noStrike">
               <a:solidFill>
                 <a:srgbClr val="000000"/>
               </a:solidFill>
@@ -2948,7 +2948,7 @@
         <p:txBody>
           <a:bodyPr/>
           <a:p>
-            <a:fld id="{CBDACC1C-18CA-4B3D-BB77-673FCF90CE60}" type="slidenum">
+            <a:fld id="{9C1E5494-628C-4560-AE17-3F0BFAC78B79}" type="slidenum">
               <a:t>&lt;#&gt;</a:t>
             </a:fld>
           </a:p>
@@ -3004,10 +3004,10 @@
             <a:noAutofit/>
           </a:bodyPr>
           <a:p>
-            <a:pPr indent="0">
-              <a:buNone/>
-            </a:pPr>
-            <a:endParaRPr b="0" lang="es-MX" sz="1400" spc="-1" strike="noStrike">
+            <a:pPr indent="0" algn="ctr">
+              <a:buNone/>
+            </a:pPr>
+            <a:endParaRPr b="0" lang="es-MX" sz="4400" spc="-1" strike="noStrike">
               <a:solidFill>
                 <a:srgbClr val="000000"/>
               </a:solidFill>
@@ -3050,7 +3050,7 @@
               </a:spcBef>
               <a:buNone/>
             </a:pPr>
-            <a:endParaRPr b="0" lang="es-MX" sz="1400" spc="-1" strike="noStrike">
+            <a:endParaRPr b="0" lang="es-MX" sz="3200" spc="-1" strike="noStrike">
               <a:solidFill>
                 <a:srgbClr val="000000"/>
               </a:solidFill>
@@ -3073,7 +3073,7 @@
         <p:txBody>
           <a:bodyPr/>
           <a:p>
-            <a:fld id="{85FD439D-939E-46D1-A849-90E465C78C36}" type="slidenum">
+            <a:fld id="{FFEDA4F6-A442-4271-9348-4C7C1B598B94}" type="slidenum">
               <a:t>&lt;#&gt;</a:t>
             </a:fld>
           </a:p>
@@ -3129,10 +3129,10 @@
             <a:noAutofit/>
           </a:bodyPr>
           <a:p>
-            <a:pPr indent="0">
-              <a:buNone/>
-            </a:pPr>
-            <a:endParaRPr b="0" lang="es-MX" sz="1400" spc="-1" strike="noStrike">
+            <a:pPr indent="0" algn="ctr">
+              <a:buNone/>
+            </a:pPr>
+            <a:endParaRPr b="0" lang="es-MX" sz="4400" spc="-1" strike="noStrike">
               <a:solidFill>
                 <a:srgbClr val="000000"/>
               </a:solidFill>
@@ -3175,7 +3175,7 @@
               </a:spcBef>
               <a:buNone/>
             </a:pPr>
-            <a:endParaRPr b="0" lang="es-MX" sz="1400" spc="-1" strike="noStrike">
+            <a:endParaRPr b="0" lang="es-MX" sz="3200" spc="-1" strike="noStrike">
               <a:solidFill>
                 <a:srgbClr val="000000"/>
               </a:solidFill>
@@ -3218,7 +3218,7 @@
               </a:spcBef>
               <a:buNone/>
             </a:pPr>
-            <a:endParaRPr b="0" lang="es-MX" sz="1400" spc="-1" strike="noStrike">
+            <a:endParaRPr b="0" lang="es-MX" sz="3200" spc="-1" strike="noStrike">
               <a:solidFill>
                 <a:srgbClr val="000000"/>
               </a:solidFill>
@@ -3241,7 +3241,7 @@
         <p:txBody>
           <a:bodyPr/>
           <a:p>
-            <a:fld id="{B10E24EC-F60B-49EA-9097-788F03F0A513}" type="slidenum">
+            <a:fld id="{8879E04E-74F7-4801-A1F9-1EC52F617E05}" type="slidenum">
               <a:t>&lt;#&gt;</a:t>
             </a:fld>
           </a:p>
@@ -3297,10 +3297,10 @@
             <a:noAutofit/>
           </a:bodyPr>
           <a:p>
-            <a:pPr indent="0">
-              <a:buNone/>
-            </a:pPr>
-            <a:endParaRPr b="0" lang="es-MX" sz="1400" spc="-1" strike="noStrike">
+            <a:pPr indent="0" algn="ctr">
+              <a:buNone/>
+            </a:pPr>
+            <a:endParaRPr b="0" lang="es-MX" sz="4400" spc="-1" strike="noStrike">
               <a:solidFill>
                 <a:srgbClr val="000000"/>
               </a:solidFill>
@@ -3323,7 +3323,7 @@
         <p:txBody>
           <a:bodyPr/>
           <a:p>
-            <a:fld id="{14D256BD-E846-474A-973E-6E3AC53715A3}" type="slidenum">
+            <a:fld id="{777AF825-8B10-4D54-8EF1-A484F3314A8D}" type="slidenum">
               <a:t>&lt;#&gt;</a:t>
             </a:fld>
           </a:p>
@@ -3403,7 +3403,7 @@
         <p:txBody>
           <a:bodyPr/>
           <a:p>
-            <a:fld id="{D89AB75C-724E-4F4E-8BED-03DAAC3AC540}" type="slidenum">
+            <a:fld id="{FF979D6C-1647-415C-A02F-B0B9A5177115}" type="slidenum">
               <a:t>&lt;#&gt;</a:t>
             </a:fld>
           </a:p>
@@ -3459,10 +3459,10 @@
             <a:noAutofit/>
           </a:bodyPr>
           <a:p>
-            <a:pPr indent="0">
-              <a:buNone/>
-            </a:pPr>
-            <a:endParaRPr b="0" lang="es-MX" sz="1400" spc="-1" strike="noStrike">
+            <a:pPr indent="0" algn="ctr">
+              <a:buNone/>
+            </a:pPr>
+            <a:endParaRPr b="0" lang="es-MX" sz="4400" spc="-1" strike="noStrike">
               <a:solidFill>
                 <a:srgbClr val="000000"/>
               </a:solidFill>
@@ -3505,7 +3505,7 @@
               </a:spcBef>
               <a:buNone/>
             </a:pPr>
-            <a:endParaRPr b="0" lang="es-MX" sz="1400" spc="-1" strike="noStrike">
+            <a:endParaRPr b="0" lang="es-MX" sz="3200" spc="-1" strike="noStrike">
               <a:solidFill>
                 <a:srgbClr val="000000"/>
               </a:solidFill>
@@ -3548,7 +3548,7 @@
               </a:spcBef>
               <a:buNone/>
             </a:pPr>
-            <a:endParaRPr b="0" lang="es-MX" sz="1400" spc="-1" strike="noStrike">
+            <a:endParaRPr b="0" lang="es-MX" sz="3200" spc="-1" strike="noStrike">
               <a:solidFill>
                 <a:srgbClr val="000000"/>
               </a:solidFill>
@@ -3591,7 +3591,7 @@
               </a:spcBef>
               <a:buNone/>
             </a:pPr>
-            <a:endParaRPr b="0" lang="es-MX" sz="1400" spc="-1" strike="noStrike">
+            <a:endParaRPr b="0" lang="es-MX" sz="3200" spc="-1" strike="noStrike">
               <a:solidFill>
                 <a:srgbClr val="000000"/>
               </a:solidFill>
@@ -3614,7 +3614,7 @@
         <p:txBody>
           <a:bodyPr/>
           <a:p>
-            <a:fld id="{C7065428-91B1-4E75-BA0F-AE4D60367643}" type="slidenum">
+            <a:fld id="{A3B62A8F-BAE3-4509-8B66-01B11ECCC772}" type="slidenum">
               <a:t>&lt;#&gt;</a:t>
             </a:fld>
           </a:p>
@@ -3670,10 +3670,10 @@
             <a:noAutofit/>
           </a:bodyPr>
           <a:p>
-            <a:pPr indent="0">
-              <a:buNone/>
-            </a:pPr>
-            <a:endParaRPr b="0" lang="es-MX" sz="1400" spc="-1" strike="noStrike">
+            <a:pPr indent="0" algn="ctr">
+              <a:buNone/>
+            </a:pPr>
+            <a:endParaRPr b="0" lang="es-MX" sz="4400" spc="-1" strike="noStrike">
               <a:solidFill>
                 <a:srgbClr val="000000"/>
               </a:solidFill>
@@ -3716,7 +3716,7 @@
               </a:spcBef>
               <a:buNone/>
             </a:pPr>
-            <a:endParaRPr b="0" lang="es-MX" sz="1400" spc="-1" strike="noStrike">
+            <a:endParaRPr b="0" lang="es-MX" sz="3200" spc="-1" strike="noStrike">
               <a:solidFill>
                 <a:srgbClr val="000000"/>
               </a:solidFill>
@@ -3759,7 +3759,7 @@
               </a:spcBef>
               <a:buNone/>
             </a:pPr>
-            <a:endParaRPr b="0" lang="es-MX" sz="1400" spc="-1" strike="noStrike">
+            <a:endParaRPr b="0" lang="es-MX" sz="3200" spc="-1" strike="noStrike">
               <a:solidFill>
                 <a:srgbClr val="000000"/>
               </a:solidFill>
@@ -3802,7 +3802,7 @@
               </a:spcBef>
               <a:buNone/>
             </a:pPr>
-            <a:endParaRPr b="0" lang="es-MX" sz="1400" spc="-1" strike="noStrike">
+            <a:endParaRPr b="0" lang="es-MX" sz="3200" spc="-1" strike="noStrike">
               <a:solidFill>
                 <a:srgbClr val="000000"/>
               </a:solidFill>
@@ -3825,7 +3825,7 @@
         <p:txBody>
           <a:bodyPr/>
           <a:p>
-            <a:fld id="{D63FBC9A-AD29-4CDC-9FD9-3EDEC2825485}" type="slidenum">
+            <a:fld id="{F0F5510B-9A89-440B-915C-75D940F8DEF6}" type="slidenum">
               <a:t>&lt;#&gt;</a:t>
             </a:fld>
           </a:p>
@@ -3881,10 +3881,10 @@
             <a:noAutofit/>
           </a:bodyPr>
           <a:p>
-            <a:pPr indent="0">
-              <a:buNone/>
-            </a:pPr>
-            <a:endParaRPr b="0" lang="es-MX" sz="1400" spc="-1" strike="noStrike">
+            <a:pPr indent="0" algn="ctr">
+              <a:buNone/>
+            </a:pPr>
+            <a:endParaRPr b="0" lang="es-MX" sz="4400" spc="-1" strike="noStrike">
               <a:solidFill>
                 <a:srgbClr val="000000"/>
               </a:solidFill>
@@ -3927,7 +3927,7 @@
               </a:spcBef>
               <a:buNone/>
             </a:pPr>
-            <a:endParaRPr b="0" lang="es-MX" sz="1400" spc="-1" strike="noStrike">
+            <a:endParaRPr b="0" lang="es-MX" sz="3200" spc="-1" strike="noStrike">
               <a:solidFill>
                 <a:srgbClr val="000000"/>
               </a:solidFill>
@@ -3970,7 +3970,7 @@
               </a:spcBef>
               <a:buNone/>
             </a:pPr>
-            <a:endParaRPr b="0" lang="es-MX" sz="1400" spc="-1" strike="noStrike">
+            <a:endParaRPr b="0" lang="es-MX" sz="3200" spc="-1" strike="noStrike">
               <a:solidFill>
                 <a:srgbClr val="000000"/>
               </a:solidFill>
@@ -4013,7 +4013,7 @@
               </a:spcBef>
               <a:buNone/>
             </a:pPr>
-            <a:endParaRPr b="0" lang="es-MX" sz="1400" spc="-1" strike="noStrike">
+            <a:endParaRPr b="0" lang="es-MX" sz="3200" spc="-1" strike="noStrike">
               <a:solidFill>
                 <a:srgbClr val="000000"/>
               </a:solidFill>
@@ -4036,7 +4036,7 @@
         <p:txBody>
           <a:bodyPr/>
           <a:p>
-            <a:fld id="{3B4708FF-5B8C-4B41-97CA-597B05A7630A}" type="slidenum">
+            <a:fld id="{899FDE53-34AC-42E3-A0E8-18729DB6ED8C}" type="slidenum">
               <a:t>&lt;#&gt;</a:t>
             </a:fld>
           </a:p>
@@ -4078,25 +4078,74 @@
             <a:spLocks noGrp="1"/>
           </p:cNvSpPr>
           <p:nvPr>
+            <p:ph type="title"/>
+          </p:nvPr>
+        </p:nvSpPr>
+        <p:spPr>
+          <a:xfrm>
+            <a:off x="457200" y="205200"/>
+            <a:ext cx="8228880" cy="858240"/>
+          </a:xfrm>
+          <a:prstGeom prst="rect">
+            <a:avLst/>
+          </a:prstGeom>
+          <a:noFill/>
+          <a:ln w="0">
+            <a:noFill/>
+          </a:ln>
+        </p:spPr>
+        <p:txBody>
+          <a:bodyPr lIns="0" rIns="0" tIns="0" bIns="0" anchor="ctr">
+            <a:noAutofit/>
+          </a:bodyPr>
+          <a:p>
+            <a:pPr indent="0">
+              <a:buNone/>
+            </a:pPr>
+            <a:r>
+              <a:rPr b="0" lang="es-MX" sz="1800" spc="-1" strike="noStrike">
+                <a:solidFill>
+                  <a:srgbClr val="000000"/>
+                </a:solidFill>
+                <a:latin typeface="Arial"/>
+              </a:rPr>
+              <a:t>Pulse para editar el formato del texto de título</a:t>
+            </a:r>
+            <a:endParaRPr b="0" lang="es-MX" sz="1800" spc="-1" strike="noStrike">
+              <a:solidFill>
+                <a:srgbClr val="000000"/>
+              </a:solidFill>
+              <a:latin typeface="Arial"/>
+            </a:endParaRPr>
+          </a:p>
+        </p:txBody>
+      </p:sp>
+      <p:sp>
+        <p:nvSpPr>
+          <p:cNvPr id="1" name="PlaceHolder 2"/>
+          <p:cNvSpPr>
+            <a:spLocks noGrp="1"/>
+          </p:cNvSpPr>
+          <p:nvPr>
             <p:ph type="sldNum" idx="1"/>
           </p:nvPr>
         </p:nvSpPr>
         <p:spPr>
           <a:xfrm>
             <a:off x="8472600" y="4663080"/>
-            <a:ext cx="548280" cy="393120"/>
-          </a:xfrm>
-          <a:prstGeom prst="rect">
-            <a:avLst/>
-          </a:prstGeom>
-          <a:noFill/>
-          <a:ln w="0">
-            <a:noFill/>
-          </a:ln>
-        </p:spPr>
-        <p:txBody>
-          <a:bodyPr tIns="91440" bIns="91440" anchor="ctr">
-            <a:normAutofit/>
+            <a:ext cx="547920" cy="392760"/>
+          </a:xfrm>
+          <a:prstGeom prst="rect">
+            <a:avLst/>
+          </a:prstGeom>
+          <a:noFill/>
+          <a:ln w="0">
+            <a:noFill/>
+          </a:ln>
+        </p:spPr>
+        <p:txBody>
+          <a:bodyPr lIns="90000" rIns="90000" tIns="91440" bIns="91440" anchor="ctr">
+            <a:noAutofit/>
           </a:bodyPr>
           <a:lstStyle>
             <a:lvl1pPr indent="0" algn="r">
@@ -4126,7 +4175,7 @@
                 <a:tab algn="l" pos="0"/>
               </a:tabLst>
             </a:pPr>
-            <a:fld id="{87318238-1FFF-4138-B4AF-5D6436621CBD}" type="slidenum">
+            <a:fld id="{6BDC99D6-452E-4B46-9C02-9848138B4BAA}" type="slidenum">
               <a:rPr b="0" lang="en" sz="1000" spc="-1" strike="noStrike">
                 <a:solidFill>
                   <a:schemeClr val="dk2"/>
@@ -4134,7 +4183,7 @@
                 <a:latin typeface="Arial"/>
                 <a:ea typeface="Arial"/>
               </a:rPr>
-              <a:t>&lt;número&gt;</a:t>
+              <a:t>5</a:t>
             </a:fld>
             <a:endParaRPr b="0" lang="es-MX" sz="1000" spc="-1" strike="noStrike">
               <a:solidFill>
@@ -4147,55 +4196,6 @@
       </p:sp>
       <p:sp>
         <p:nvSpPr>
-          <p:cNvPr id="1" name="PlaceHolder 2"/>
-          <p:cNvSpPr>
-            <a:spLocks noGrp="1"/>
-          </p:cNvSpPr>
-          <p:nvPr>
-            <p:ph type="title"/>
-          </p:nvPr>
-        </p:nvSpPr>
-        <p:spPr>
-          <a:xfrm>
-            <a:off x="457200" y="205200"/>
-            <a:ext cx="8229240" cy="858600"/>
-          </a:xfrm>
-          <a:prstGeom prst="rect">
-            <a:avLst/>
-          </a:prstGeom>
-          <a:noFill/>
-          <a:ln w="0">
-            <a:noFill/>
-          </a:ln>
-        </p:spPr>
-        <p:txBody>
-          <a:bodyPr lIns="0" rIns="0" tIns="0" bIns="0" anchor="ctr">
-            <a:noAutofit/>
-          </a:bodyPr>
-          <a:p>
-            <a:pPr indent="0">
-              <a:buNone/>
-            </a:pPr>
-            <a:r>
-              <a:rPr b="0" lang="es-MX" sz="1400" spc="-1" strike="noStrike">
-                <a:solidFill>
-                  <a:srgbClr val="000000"/>
-                </a:solidFill>
-                <a:latin typeface="Arial"/>
-              </a:rPr>
-              <a:t>Pulse para editar el formato del texto de título</a:t>
-            </a:r>
-            <a:endParaRPr b="0" lang="es-MX" sz="1400" spc="-1" strike="noStrike">
-              <a:solidFill>
-                <a:srgbClr val="000000"/>
-              </a:solidFill>
-              <a:latin typeface="Arial"/>
-            </a:endParaRPr>
-          </a:p>
-        </p:txBody>
-      </p:sp>
-      <p:sp>
-        <p:nvSpPr>
           <p:cNvPr id="2" name="PlaceHolder 3"/>
           <p:cNvSpPr>
             <a:spLocks noGrp="1"/>
@@ -4219,10 +4219,10 @@
         </p:spPr>
         <p:txBody>
           <a:bodyPr lIns="0" rIns="0" tIns="0" bIns="0" anchor="t">
-            <a:normAutofit/>
-          </a:bodyPr>
-          <a:p>
-            <a:pPr marL="432000" indent="-324000">
+            <a:normAutofit fontScale="96000"/>
+          </a:bodyPr>
+          <a:p>
+            <a:pPr marL="414720" indent="-311040">
               <a:spcBef>
                 <a:spcPts val="1417"/>
               </a:spcBef>
@@ -4234,7 +4234,7 @@
               <a:buChar char=""/>
             </a:pPr>
             <a:r>
-              <a:rPr b="0" lang="es-MX" sz="1400" spc="-1" strike="noStrike">
+              <a:rPr b="0" lang="es-MX" sz="3200" spc="-1" strike="noStrike">
                 <a:solidFill>
                   <a:srgbClr val="000000"/>
                 </a:solidFill>
@@ -4242,15 +4242,15 @@
               </a:rPr>
               <a:t>Pulse para editar el formato de texto del esquema</a:t>
             </a:r>
-            <a:endParaRPr b="0" lang="es-MX" sz="1400" spc="-1" strike="noStrike">
-              <a:solidFill>
-                <a:srgbClr val="000000"/>
-              </a:solidFill>
-              <a:latin typeface="Arial"/>
-            </a:endParaRPr>
-          </a:p>
-          <a:p>
-            <a:pPr lvl="1" marL="864000" indent="-324000">
+            <a:endParaRPr b="0" lang="es-MX" sz="3200" spc="-1" strike="noStrike">
+              <a:solidFill>
+                <a:srgbClr val="000000"/>
+              </a:solidFill>
+              <a:latin typeface="Arial"/>
+            </a:endParaRPr>
+          </a:p>
+          <a:p>
+            <a:pPr lvl="1" marL="829440" indent="-311040">
               <a:spcBef>
                 <a:spcPts val="1134"/>
               </a:spcBef>
@@ -4262,7 +4262,7 @@
               <a:buChar char=""/>
             </a:pPr>
             <a:r>
-              <a:rPr b="0" lang="es-MX" sz="1400" spc="-1" strike="noStrike">
+              <a:rPr b="0" lang="es-MX" sz="2800" spc="-1" strike="noStrike">
                 <a:solidFill>
                   <a:srgbClr val="000000"/>
                 </a:solidFill>
@@ -4270,15 +4270,15 @@
               </a:rPr>
               <a:t>Segundo nivel del esquema</a:t>
             </a:r>
-            <a:endParaRPr b="0" lang="es-MX" sz="1400" spc="-1" strike="noStrike">
-              <a:solidFill>
-                <a:srgbClr val="000000"/>
-              </a:solidFill>
-              <a:latin typeface="Arial"/>
-            </a:endParaRPr>
-          </a:p>
-          <a:p>
-            <a:pPr lvl="2" marL="1296000" indent="-288000">
+            <a:endParaRPr b="0" lang="es-MX" sz="2800" spc="-1" strike="noStrike">
+              <a:solidFill>
+                <a:srgbClr val="000000"/>
+              </a:solidFill>
+              <a:latin typeface="Arial"/>
+            </a:endParaRPr>
+          </a:p>
+          <a:p>
+            <a:pPr lvl="2" marL="1244160" indent="-276480">
               <a:spcBef>
                 <a:spcPts val="850"/>
               </a:spcBef>
@@ -4290,7 +4290,7 @@
               <a:buChar char=""/>
             </a:pPr>
             <a:r>
-              <a:rPr b="0" lang="es-MX" sz="1400" spc="-1" strike="noStrike">
+              <a:rPr b="0" lang="es-MX" sz="2400" spc="-1" strike="noStrike">
                 <a:solidFill>
                   <a:srgbClr val="000000"/>
                 </a:solidFill>
@@ -4298,15 +4298,15 @@
               </a:rPr>
               <a:t>Tercer nivel del esquema</a:t>
             </a:r>
-            <a:endParaRPr b="0" lang="es-MX" sz="1400" spc="-1" strike="noStrike">
-              <a:solidFill>
-                <a:srgbClr val="000000"/>
-              </a:solidFill>
-              <a:latin typeface="Arial"/>
-            </a:endParaRPr>
-          </a:p>
-          <a:p>
-            <a:pPr lvl="3" marL="1728000" indent="-216000">
+            <a:endParaRPr b="0" lang="es-MX" sz="2400" spc="-1" strike="noStrike">
+              <a:solidFill>
+                <a:srgbClr val="000000"/>
+              </a:solidFill>
+              <a:latin typeface="Arial"/>
+            </a:endParaRPr>
+          </a:p>
+          <a:p>
+            <a:pPr lvl="3" marL="1658880" indent="-207360">
               <a:spcBef>
                 <a:spcPts val="567"/>
               </a:spcBef>
@@ -4318,7 +4318,7 @@
               <a:buChar char=""/>
             </a:pPr>
             <a:r>
-              <a:rPr b="0" lang="es-MX" sz="1400" spc="-1" strike="noStrike">
+              <a:rPr b="0" lang="es-MX" sz="2000" spc="-1" strike="noStrike">
                 <a:solidFill>
                   <a:srgbClr val="000000"/>
                 </a:solidFill>
@@ -4326,15 +4326,15 @@
               </a:rPr>
               <a:t>Cuarto nivel del esquema</a:t>
             </a:r>
-            <a:endParaRPr b="0" lang="es-MX" sz="1400" spc="-1" strike="noStrike">
-              <a:solidFill>
-                <a:srgbClr val="000000"/>
-              </a:solidFill>
-              <a:latin typeface="Arial"/>
-            </a:endParaRPr>
-          </a:p>
-          <a:p>
-            <a:pPr lvl="4" marL="2160000" indent="-216000">
+            <a:endParaRPr b="0" lang="es-MX" sz="2000" spc="-1" strike="noStrike">
+              <a:solidFill>
+                <a:srgbClr val="000000"/>
+              </a:solidFill>
+              <a:latin typeface="Arial"/>
+            </a:endParaRPr>
+          </a:p>
+          <a:p>
+            <a:pPr lvl="4" marL="2073600" indent="-207360">
               <a:spcBef>
                 <a:spcPts val="283"/>
               </a:spcBef>
@@ -4362,7 +4362,7 @@
             </a:endParaRPr>
           </a:p>
           <a:p>
-            <a:pPr lvl="5" marL="2592000" indent="-216000">
+            <a:pPr lvl="5" marL="2488320" indent="-207360">
               <a:spcBef>
                 <a:spcPts val="283"/>
               </a:spcBef>
@@ -4390,7 +4390,7 @@
             </a:endParaRPr>
           </a:p>
           <a:p>
-            <a:pPr lvl="6" marL="3024000" indent="-216000">
+            <a:pPr lvl="6" marL="2903040" indent="-207360">
               <a:spcBef>
                 <a:spcPts val="283"/>
               </a:spcBef>
@@ -4476,19 +4476,19 @@
         <p:spPr>
           <a:xfrm>
             <a:off x="8472600" y="4663080"/>
-            <a:ext cx="548280" cy="393120"/>
-          </a:xfrm>
-          <a:prstGeom prst="rect">
-            <a:avLst/>
-          </a:prstGeom>
-          <a:noFill/>
-          <a:ln w="0">
-            <a:noFill/>
-          </a:ln>
-        </p:spPr>
-        <p:txBody>
-          <a:bodyPr tIns="91440" bIns="91440" anchor="ctr">
-            <a:normAutofit/>
+            <a:ext cx="547920" cy="392760"/>
+          </a:xfrm>
+          <a:prstGeom prst="rect">
+            <a:avLst/>
+          </a:prstGeom>
+          <a:noFill/>
+          <a:ln w="0">
+            <a:noFill/>
+          </a:ln>
+        </p:spPr>
+        <p:txBody>
+          <a:bodyPr lIns="90000" rIns="90000" tIns="91440" bIns="91440" anchor="ctr">
+            <a:noAutofit/>
           </a:bodyPr>
           <a:lstStyle>
             <a:lvl1pPr indent="0" algn="r">
@@ -4518,7 +4518,7 @@
                 <a:tab algn="l" pos="0"/>
               </a:tabLst>
             </a:pPr>
-            <a:fld id="{B8F3ACEF-8527-4112-85D3-906064609C12}" type="slidenum">
+            <a:fld id="{33372394-D000-4583-BD92-A51E6D66AD67}" type="slidenum">
               <a:rPr b="0" lang="en" sz="1000" spc="-1" strike="noStrike">
                 <a:solidFill>
                   <a:schemeClr val="dk2"/>
@@ -4565,11 +4565,11 @@
             <a:noAutofit/>
           </a:bodyPr>
           <a:p>
-            <a:pPr indent="0">
+            <a:pPr indent="0" algn="ctr">
               <a:buNone/>
             </a:pPr>
             <a:r>
-              <a:rPr b="0" lang="es-MX" sz="1400" spc="-1" strike="noStrike">
+              <a:rPr b="0" lang="es-MX" sz="4400" spc="-1" strike="noStrike">
                 <a:solidFill>
                   <a:srgbClr val="000000"/>
                 </a:solidFill>
@@ -4577,7 +4577,7 @@
               </a:rPr>
               <a:t>Pulse para editar el formato del texto de título</a:t>
             </a:r>
-            <a:endParaRPr b="0" lang="es-MX" sz="1400" spc="-1" strike="noStrike">
+            <a:endParaRPr b="0" lang="es-MX" sz="4400" spc="-1" strike="noStrike">
               <a:solidFill>
                 <a:srgbClr val="000000"/>
               </a:solidFill>
@@ -4611,10 +4611,10 @@
         </p:spPr>
         <p:txBody>
           <a:bodyPr lIns="0" rIns="0" tIns="0" bIns="0" anchor="t">
-            <a:normAutofit/>
-          </a:bodyPr>
-          <a:p>
-            <a:pPr marL="432000" indent="-324000">
+            <a:normAutofit fontScale="96000"/>
+          </a:bodyPr>
+          <a:p>
+            <a:pPr marL="414720" indent="-311040">
               <a:spcBef>
                 <a:spcPts val="1417"/>
               </a:spcBef>
@@ -4626,7 +4626,7 @@
               <a:buChar char=""/>
             </a:pPr>
             <a:r>
-              <a:rPr b="0" lang="es-MX" sz="1400" spc="-1" strike="noStrike">
+              <a:rPr b="0" lang="es-MX" sz="3200" spc="-1" strike="noStrike">
                 <a:solidFill>
                   <a:srgbClr val="000000"/>
                 </a:solidFill>
@@ -4634,15 +4634,15 @@
               </a:rPr>
               <a:t>Pulse para editar el formato de texto del esquema</a:t>
             </a:r>
-            <a:endParaRPr b="0" lang="es-MX" sz="1400" spc="-1" strike="noStrike">
-              <a:solidFill>
-                <a:srgbClr val="000000"/>
-              </a:solidFill>
-              <a:latin typeface="Arial"/>
-            </a:endParaRPr>
-          </a:p>
-          <a:p>
-            <a:pPr lvl="1" marL="864000" indent="-324000">
+            <a:endParaRPr b="0" lang="es-MX" sz="3200" spc="-1" strike="noStrike">
+              <a:solidFill>
+                <a:srgbClr val="000000"/>
+              </a:solidFill>
+              <a:latin typeface="Arial"/>
+            </a:endParaRPr>
+          </a:p>
+          <a:p>
+            <a:pPr lvl="1" marL="829440" indent="-311040">
               <a:spcBef>
                 <a:spcPts val="1134"/>
               </a:spcBef>
@@ -4654,7 +4654,7 @@
               <a:buChar char=""/>
             </a:pPr>
             <a:r>
-              <a:rPr b="0" lang="es-MX" sz="1400" spc="-1" strike="noStrike">
+              <a:rPr b="0" lang="es-MX" sz="2800" spc="-1" strike="noStrike">
                 <a:solidFill>
                   <a:srgbClr val="000000"/>
                 </a:solidFill>
@@ -4662,15 +4662,15 @@
               </a:rPr>
               <a:t>Segundo nivel del esquema</a:t>
             </a:r>
-            <a:endParaRPr b="0" lang="es-MX" sz="1400" spc="-1" strike="noStrike">
-              <a:solidFill>
-                <a:srgbClr val="000000"/>
-              </a:solidFill>
-              <a:latin typeface="Arial"/>
-            </a:endParaRPr>
-          </a:p>
-          <a:p>
-            <a:pPr lvl="2" marL="1296000" indent="-288000">
+            <a:endParaRPr b="0" lang="es-MX" sz="2800" spc="-1" strike="noStrike">
+              <a:solidFill>
+                <a:srgbClr val="000000"/>
+              </a:solidFill>
+              <a:latin typeface="Arial"/>
+            </a:endParaRPr>
+          </a:p>
+          <a:p>
+            <a:pPr lvl="2" marL="1244160" indent="-276480">
               <a:spcBef>
                 <a:spcPts val="850"/>
               </a:spcBef>
@@ -4682,7 +4682,7 @@
               <a:buChar char=""/>
             </a:pPr>
             <a:r>
-              <a:rPr b="0" lang="es-MX" sz="1400" spc="-1" strike="noStrike">
+              <a:rPr b="0" lang="es-MX" sz="2400" spc="-1" strike="noStrike">
                 <a:solidFill>
                   <a:srgbClr val="000000"/>
                 </a:solidFill>
@@ -4690,15 +4690,15 @@
               </a:rPr>
               <a:t>Tercer nivel del esquema</a:t>
             </a:r>
-            <a:endParaRPr b="0" lang="es-MX" sz="1400" spc="-1" strike="noStrike">
-              <a:solidFill>
-                <a:srgbClr val="000000"/>
-              </a:solidFill>
-              <a:latin typeface="Arial"/>
-            </a:endParaRPr>
-          </a:p>
-          <a:p>
-            <a:pPr lvl="3" marL="1728000" indent="-216000">
+            <a:endParaRPr b="0" lang="es-MX" sz="2400" spc="-1" strike="noStrike">
+              <a:solidFill>
+                <a:srgbClr val="000000"/>
+              </a:solidFill>
+              <a:latin typeface="Arial"/>
+            </a:endParaRPr>
+          </a:p>
+          <a:p>
+            <a:pPr lvl="3" marL="1658880" indent="-207360">
               <a:spcBef>
                 <a:spcPts val="567"/>
               </a:spcBef>
@@ -4710,7 +4710,7 @@
               <a:buChar char=""/>
             </a:pPr>
             <a:r>
-              <a:rPr b="0" lang="es-MX" sz="1400" spc="-1" strike="noStrike">
+              <a:rPr b="0" lang="es-MX" sz="2000" spc="-1" strike="noStrike">
                 <a:solidFill>
                   <a:srgbClr val="000000"/>
                 </a:solidFill>
@@ -4718,15 +4718,15 @@
               </a:rPr>
               <a:t>Cuarto nivel del esquema</a:t>
             </a:r>
-            <a:endParaRPr b="0" lang="es-MX" sz="1400" spc="-1" strike="noStrike">
-              <a:solidFill>
-                <a:srgbClr val="000000"/>
-              </a:solidFill>
-              <a:latin typeface="Arial"/>
-            </a:endParaRPr>
-          </a:p>
-          <a:p>
-            <a:pPr lvl="4" marL="2160000" indent="-216000">
+            <a:endParaRPr b="0" lang="es-MX" sz="2000" spc="-1" strike="noStrike">
+              <a:solidFill>
+                <a:srgbClr val="000000"/>
+              </a:solidFill>
+              <a:latin typeface="Arial"/>
+            </a:endParaRPr>
+          </a:p>
+          <a:p>
+            <a:pPr lvl="4" marL="2073600" indent="-207360">
               <a:spcBef>
                 <a:spcPts val="283"/>
               </a:spcBef>
@@ -4754,7 +4754,7 @@
             </a:endParaRPr>
           </a:p>
           <a:p>
-            <a:pPr lvl="5" marL="2592000" indent="-216000">
+            <a:pPr lvl="5" marL="2488320" indent="-207360">
               <a:spcBef>
                 <a:spcPts val="283"/>
               </a:spcBef>
@@ -4782,7 +4782,7 @@
             </a:endParaRPr>
           </a:p>
           <a:p>
-            <a:pPr lvl="6" marL="3024000" indent="-216000">
+            <a:pPr lvl="6" marL="2903040" indent="-207360">
               <a:spcBef>
                 <a:spcPts val="283"/>
               </a:spcBef>
@@ -4868,18 +4868,18 @@
         <p:spPr>
           <a:xfrm>
             <a:off x="64080" y="638280"/>
-            <a:ext cx="8520120" cy="2169720"/>
-          </a:xfrm>
-          <a:prstGeom prst="rect">
-            <a:avLst/>
-          </a:prstGeom>
-          <a:noFill/>
-          <a:ln w="0">
-            <a:noFill/>
-          </a:ln>
-        </p:spPr>
-        <p:txBody>
-          <a:bodyPr tIns="0" bIns="91440" anchor="t">
+            <a:ext cx="8519760" cy="2169360"/>
+          </a:xfrm>
+          <a:prstGeom prst="rect">
+            <a:avLst/>
+          </a:prstGeom>
+          <a:noFill/>
+          <a:ln w="0">
+            <a:noFill/>
+          </a:ln>
+        </p:spPr>
+        <p:txBody>
+          <a:bodyPr lIns="0" rIns="0" tIns="0" bIns="91440" anchor="t">
             <a:noAutofit/>
           </a:bodyPr>
           <a:p>
@@ -4954,7 +4954,7 @@
         <p:spPr>
           <a:xfrm>
             <a:off x="228600" y="228600"/>
-            <a:ext cx="866520" cy="194040"/>
+            <a:ext cx="866160" cy="193680"/>
           </a:xfrm>
           <a:prstGeom prst="rect">
             <a:avLst/>
@@ -5014,18 +5014,18 @@
         <p:spPr>
           <a:xfrm>
             <a:off x="152280" y="2017800"/>
-            <a:ext cx="8520120" cy="2989440"/>
-          </a:xfrm>
-          <a:prstGeom prst="rect">
-            <a:avLst/>
-          </a:prstGeom>
-          <a:noFill/>
-          <a:ln w="0">
-            <a:noFill/>
-          </a:ln>
-        </p:spPr>
-        <p:txBody>
-          <a:bodyPr tIns="91440" bIns="91440" anchor="b">
+            <a:ext cx="8519760" cy="2989080"/>
+          </a:xfrm>
+          <a:prstGeom prst="rect">
+            <a:avLst/>
+          </a:prstGeom>
+          <a:noFill/>
+          <a:ln w="0">
+            <a:noFill/>
+          </a:ln>
+        </p:spPr>
+        <p:txBody>
+          <a:bodyPr lIns="0" rIns="0" tIns="91440" bIns="91440" anchor="b">
             <a:noAutofit/>
           </a:bodyPr>
           <a:p>
@@ -5083,15 +5083,10 @@
             </a:endParaRPr>
           </a:p>
           <a:p>
-            <a:pPr marL="457200" indent="-380880">
+            <a:pPr>
               <a:lnSpc>
                 <a:spcPct val="100000"/>
               </a:lnSpc>
-              <a:buClr>
-                <a:srgbClr val="1a1a1a"/>
-              </a:buClr>
-              <a:buFont typeface="Inter"/>
-              <a:buAutoNum type="arabicPeriod"/>
             </a:pPr>
             <a:endParaRPr b="0" lang="es-MX" sz="2400" spc="-1" strike="noStrike">
               <a:solidFill>
@@ -5115,7 +5110,7 @@
         <p:spPr>
           <a:xfrm>
             <a:off x="228600" y="228600"/>
-            <a:ext cx="866520" cy="194040"/>
+            <a:ext cx="866160" cy="193680"/>
           </a:xfrm>
           <a:prstGeom prst="rect">
             <a:avLst/>
@@ -5138,18 +5133,18 @@
         <p:spPr>
           <a:xfrm>
             <a:off x="96840" y="424800"/>
-            <a:ext cx="8520120" cy="1041840"/>
-          </a:xfrm>
-          <a:prstGeom prst="rect">
-            <a:avLst/>
-          </a:prstGeom>
-          <a:noFill/>
-          <a:ln w="0">
-            <a:noFill/>
-          </a:ln>
-        </p:spPr>
-        <p:txBody>
-          <a:bodyPr tIns="91440" bIns="91440" anchor="t">
+            <a:ext cx="8519760" cy="1041480"/>
+          </a:xfrm>
+          <a:prstGeom prst="rect">
+            <a:avLst/>
+          </a:prstGeom>
+          <a:noFill/>
+          <a:ln w="0">
+            <a:noFill/>
+          </a:ln>
+        </p:spPr>
+        <p:txBody>
+          <a:bodyPr lIns="0" rIns="0" tIns="91440" bIns="91440" anchor="t">
             <a:noAutofit/>
           </a:bodyPr>
           <a:p>
@@ -5227,7 +5222,7 @@
         <p:spPr>
           <a:xfrm>
             <a:off x="228600" y="1952280"/>
-            <a:ext cx="2724480" cy="2962080"/>
+            <a:ext cx="2724120" cy="2961720"/>
           </a:xfrm>
           <a:prstGeom prst="roundRect">
             <a:avLst>
@@ -5288,7 +5283,7 @@
         <p:spPr>
           <a:xfrm>
             <a:off x="3209400" y="1952280"/>
-            <a:ext cx="2724480" cy="2962080"/>
+            <a:ext cx="2724120" cy="2961720"/>
           </a:xfrm>
           <a:prstGeom prst="roundRect">
             <a:avLst>
@@ -5349,7 +5344,7 @@
         <p:spPr>
           <a:xfrm>
             <a:off x="6190560" y="1952280"/>
-            <a:ext cx="2724480" cy="2962080"/>
+            <a:ext cx="2724120" cy="2961720"/>
           </a:xfrm>
           <a:prstGeom prst="roundRect">
             <a:avLst>
@@ -5414,7 +5409,7 @@
         <p:spPr>
           <a:xfrm>
             <a:off x="228600" y="228600"/>
-            <a:ext cx="866520" cy="194040"/>
+            <a:ext cx="866160" cy="193680"/>
           </a:xfrm>
           <a:prstGeom prst="rect">
             <a:avLst/>
@@ -5437,18 +5432,18 @@
         <p:spPr>
           <a:xfrm>
             <a:off x="96840" y="424800"/>
-            <a:ext cx="8520120" cy="1041840"/>
-          </a:xfrm>
-          <a:prstGeom prst="rect">
-            <a:avLst/>
-          </a:prstGeom>
-          <a:noFill/>
-          <a:ln w="0">
-            <a:noFill/>
-          </a:ln>
-        </p:spPr>
-        <p:txBody>
-          <a:bodyPr tIns="91440" bIns="91440" anchor="t">
+            <a:ext cx="8519760" cy="1041480"/>
+          </a:xfrm>
+          <a:prstGeom prst="rect">
+            <a:avLst/>
+          </a:prstGeom>
+          <a:noFill/>
+          <a:ln w="0">
+            <a:noFill/>
+          </a:ln>
+        </p:spPr>
+        <p:txBody>
+          <a:bodyPr lIns="0" rIns="0" tIns="91440" bIns="91440" anchor="t">
             <a:noAutofit/>
           </a:bodyPr>
           <a:p>
@@ -5493,7 +5488,7 @@
         <p:spPr>
           <a:xfrm>
             <a:off x="424800" y="2191320"/>
-            <a:ext cx="474120" cy="760320"/>
+            <a:ext cx="473760" cy="759960"/>
           </a:xfrm>
           <a:prstGeom prst="rect">
             <a:avLst/>
@@ -5516,7 +5511,7 @@
         <p:spPr>
           <a:xfrm>
             <a:off x="3468960" y="2191320"/>
-            <a:ext cx="474120" cy="760320"/>
+            <a:ext cx="473760" cy="759960"/>
           </a:xfrm>
           <a:prstGeom prst="rect">
             <a:avLst/>
@@ -5539,7 +5534,7 @@
         <p:spPr>
           <a:xfrm>
             <a:off x="6407280" y="2191320"/>
-            <a:ext cx="474120" cy="760320"/>
+            <a:ext cx="473760" cy="759960"/>
           </a:xfrm>
           <a:prstGeom prst="rect">
             <a:avLst/>
@@ -5599,7 +5594,7 @@
         <p:spPr>
           <a:xfrm>
             <a:off x="228600" y="228600"/>
-            <a:ext cx="866520" cy="194040"/>
+            <a:ext cx="866160" cy="193680"/>
           </a:xfrm>
           <a:prstGeom prst="rect">
             <a:avLst/>
@@ -5622,18 +5617,18 @@
         <p:spPr>
           <a:xfrm>
             <a:off x="322920" y="817560"/>
-            <a:ext cx="6138000" cy="3475080"/>
-          </a:xfrm>
-          <a:prstGeom prst="rect">
-            <a:avLst/>
-          </a:prstGeom>
-          <a:noFill/>
-          <a:ln w="0">
-            <a:noFill/>
-          </a:ln>
-        </p:spPr>
-        <p:txBody>
-          <a:bodyPr tIns="91440" bIns="91440" anchor="t">
+            <a:ext cx="6137640" cy="3474720"/>
+          </a:xfrm>
+          <a:prstGeom prst="rect">
+            <a:avLst/>
+          </a:prstGeom>
+          <a:noFill/>
+          <a:ln w="0">
+            <a:noFill/>
+          </a:ln>
+        </p:spPr>
+        <p:txBody>
+          <a:bodyPr lIns="0" rIns="0" tIns="91440" bIns="91440" anchor="t">
             <a:noAutofit/>
           </a:bodyPr>
           <a:p>
@@ -5715,18 +5710,18 @@
         <p:spPr>
           <a:xfrm>
             <a:off x="96840" y="2386440"/>
-            <a:ext cx="8520120" cy="2527920"/>
-          </a:xfrm>
-          <a:prstGeom prst="rect">
-            <a:avLst/>
-          </a:prstGeom>
-          <a:noFill/>
-          <a:ln w="0">
-            <a:noFill/>
-          </a:ln>
-        </p:spPr>
-        <p:txBody>
-          <a:bodyPr tIns="91440" bIns="91440" anchor="b">
+            <a:ext cx="8519760" cy="2527560"/>
+          </a:xfrm>
+          <a:prstGeom prst="rect">
+            <a:avLst/>
+          </a:prstGeom>
+          <a:noFill/>
+          <a:ln w="0">
+            <a:noFill/>
+          </a:ln>
+        </p:spPr>
+        <p:txBody>
+          <a:bodyPr lIns="0" rIns="0" tIns="91440" bIns="91440" anchor="b">
             <a:noAutofit/>
           </a:bodyPr>
           <a:p>
@@ -5751,7 +5746,7 @@
             </a:r>
             <a:endParaRPr b="0" lang="es-MX" sz="4800" spc="-1" strike="noStrike">
               <a:solidFill>
-                <a:srgbClr val="000000"/>
+                <a:srgbClr val="ffffff"/>
               </a:solidFill>
               <a:latin typeface="Arial"/>
             </a:endParaRPr>
@@ -5771,7 +5766,7 @@
         <p:spPr>
           <a:xfrm>
             <a:off x="228600" y="228600"/>
-            <a:ext cx="868320" cy="191520"/>
+            <a:ext cx="867960" cy="191160"/>
           </a:xfrm>
           <a:prstGeom prst="rect">
             <a:avLst/>
@@ -5831,7 +5826,7 @@
         <p:spPr>
           <a:xfrm>
             <a:off x="228600" y="228600"/>
-            <a:ext cx="866520" cy="194040"/>
+            <a:ext cx="866160" cy="193680"/>
           </a:xfrm>
           <a:prstGeom prst="rect">
             <a:avLst/>
@@ -5854,18 +5849,18 @@
         <p:spPr>
           <a:xfrm>
             <a:off x="322920" y="817560"/>
-            <a:ext cx="6138000" cy="2652120"/>
-          </a:xfrm>
-          <a:prstGeom prst="rect">
-            <a:avLst/>
-          </a:prstGeom>
-          <a:noFill/>
-          <a:ln w="0">
-            <a:noFill/>
-          </a:ln>
-        </p:spPr>
-        <p:txBody>
-          <a:bodyPr tIns="91440" bIns="91440" anchor="t">
+            <a:ext cx="6137640" cy="2651760"/>
+          </a:xfrm>
+          <a:prstGeom prst="rect">
+            <a:avLst/>
+          </a:prstGeom>
+          <a:noFill/>
+          <a:ln w="0">
+            <a:noFill/>
+          </a:ln>
+        </p:spPr>
+        <p:txBody>
+          <a:bodyPr lIns="0" rIns="0" tIns="91440" bIns="91440" anchor="t">
             <a:noAutofit/>
           </a:bodyPr>
           <a:p>
@@ -5947,18 +5942,18 @@
         <p:spPr>
           <a:xfrm>
             <a:off x="311760" y="1914120"/>
-            <a:ext cx="8520120" cy="1041840"/>
-          </a:xfrm>
-          <a:prstGeom prst="rect">
-            <a:avLst/>
-          </a:prstGeom>
-          <a:noFill/>
-          <a:ln w="0">
-            <a:noFill/>
-          </a:ln>
-        </p:spPr>
-        <p:txBody>
-          <a:bodyPr tIns="91440" bIns="91440" anchor="t">
+            <a:ext cx="8519760" cy="1041480"/>
+          </a:xfrm>
+          <a:prstGeom prst="rect">
+            <a:avLst/>
+          </a:prstGeom>
+          <a:noFill/>
+          <a:ln w="0">
+            <a:noFill/>
+          </a:ln>
+        </p:spPr>
+        <p:txBody>
+          <a:bodyPr lIns="0" rIns="0" tIns="91440" bIns="91440" anchor="t">
             <a:noAutofit/>
           </a:bodyPr>
           <a:p>
@@ -6003,7 +5998,7 @@
         <p:spPr>
           <a:xfrm>
             <a:off x="3642120" y="2053080"/>
-            <a:ext cx="645120" cy="644760"/>
+            <a:ext cx="644760" cy="644400"/>
           </a:xfrm>
           <a:prstGeom prst="rect">
             <a:avLst/>
@@ -6026,7 +6021,7 @@
         <p:spPr>
           <a:xfrm>
             <a:off x="4138560" y="228600"/>
-            <a:ext cx="866520" cy="194040"/>
+            <a:ext cx="866160" cy="193680"/>
           </a:xfrm>
           <a:prstGeom prst="rect">
             <a:avLst/>

</xml_diff>

<commit_message>
Updates DA S13 Introduccion a ML
</commit_message>
<xml_diff>
--- a/07-herramientas-desarrollo/14-git.pptx
+++ b/07-herramientas-desarrollo/14-git.pptx
@@ -50,7 +50,7 @@
         <p:txBody>
           <a:bodyPr/>
           <a:p>
-            <a:fld id="{52139788-0820-43E5-90AC-38F921DB00C5}" type="slidenum">
+            <a:fld id="{38A3E6C6-A7B1-46ED-93AC-63F329362615}" type="slidenum">
               <a:t>&lt;#&gt;</a:t>
             </a:fld>
           </a:p>
@@ -218,7 +218,7 @@
         <p:txBody>
           <a:bodyPr/>
           <a:p>
-            <a:fld id="{CD5387F5-DC33-4920-8797-A7F5DD2E0ACA}" type="slidenum">
+            <a:fld id="{1C45C0AA-B630-443F-AEA6-B7FAB40A0D87}" type="slidenum">
               <a:t>&lt;#&gt;</a:t>
             </a:fld>
           </a:p>
@@ -472,7 +472,7 @@
         <p:txBody>
           <a:bodyPr/>
           <a:p>
-            <a:fld id="{C7D926CA-7CF8-410F-8665-6630DDBC83D2}" type="slidenum">
+            <a:fld id="{E9C0B747-8A0B-468B-9044-4B558DD06E71}" type="slidenum">
               <a:t>&lt;#&gt;</a:t>
             </a:fld>
           </a:p>
@@ -812,7 +812,7 @@
         <p:txBody>
           <a:bodyPr/>
           <a:p>
-            <a:fld id="{25D35878-4A41-492F-8180-3BEF593DAB8B}" type="slidenum">
+            <a:fld id="{D0BBD4D2-D9C5-4466-B7A1-6FEDBC7D3ED6}" type="slidenum">
               <a:t>&lt;#&gt;</a:t>
             </a:fld>
           </a:p>
@@ -854,7 +854,7 @@
         <p:txBody>
           <a:bodyPr/>
           <a:p>
-            <a:fld id="{62463B25-DD8E-4FA8-9084-295899C06FF0}" type="slidenum">
+            <a:fld id="{CA1097FA-BE7C-4098-B482-C4EBBF901DA2}" type="slidenum">
               <a:t>&lt;#&gt;</a:t>
             </a:fld>
           </a:p>
@@ -976,7 +976,7 @@
         <p:txBody>
           <a:bodyPr/>
           <a:p>
-            <a:fld id="{34E13E23-DE2C-49A2-85F4-776913D1355F}" type="slidenum">
+            <a:fld id="{0F1B16AC-345E-48B9-B0ED-70226F7E874B}" type="slidenum">
               <a:t>&lt;#&gt;</a:t>
             </a:fld>
           </a:p>
@@ -1101,7 +1101,7 @@
         <p:txBody>
           <a:bodyPr/>
           <a:p>
-            <a:fld id="{000F8ED2-A26D-4D9F-B34A-2C5DD8AAA4E9}" type="slidenum">
+            <a:fld id="{7D3AD8D0-200A-4E33-A803-C16F5F4DDF58}" type="slidenum">
               <a:t>&lt;#&gt;</a:t>
             </a:fld>
           </a:p>
@@ -1269,7 +1269,7 @@
         <p:txBody>
           <a:bodyPr/>
           <a:p>
-            <a:fld id="{92DCE6E1-CFD8-4A27-A576-A014F907A813}" type="slidenum">
+            <a:fld id="{F7912B5E-BF75-4753-A4D4-C40E4A50B857}" type="slidenum">
               <a:t>&lt;#&gt;</a:t>
             </a:fld>
           </a:p>
@@ -1351,7 +1351,7 @@
         <p:txBody>
           <a:bodyPr/>
           <a:p>
-            <a:fld id="{9960679A-B609-4EDF-BF9A-5126733072AD}" type="slidenum">
+            <a:fld id="{7B160FB8-5E38-489B-8220-B741170599BC}" type="slidenum">
               <a:t>&lt;#&gt;</a:t>
             </a:fld>
           </a:p>
@@ -1431,7 +1431,7 @@
         <p:txBody>
           <a:bodyPr/>
           <a:p>
-            <a:fld id="{83583EAA-F8D5-4D29-94E1-8262A3904874}" type="slidenum">
+            <a:fld id="{8389AE46-6AE5-48E9-9641-3E29A048D03E}" type="slidenum">
               <a:t>&lt;#&gt;</a:t>
             </a:fld>
           </a:p>
@@ -1642,7 +1642,7 @@
         <p:txBody>
           <a:bodyPr/>
           <a:p>
-            <a:fld id="{84575AD2-E6A1-4FFD-A63F-F9A1AFBF9EA3}" type="slidenum">
+            <a:fld id="{CA4F87A0-1348-41C3-9127-C577D6D0B376}" type="slidenum">
               <a:t>&lt;#&gt;</a:t>
             </a:fld>
           </a:p>
@@ -1764,7 +1764,7 @@
         <p:txBody>
           <a:bodyPr/>
           <a:p>
-            <a:fld id="{1B817EF8-0D7A-424E-8FB6-476EA10FB107}" type="slidenum">
+            <a:fld id="{D6FEACFB-220E-47CE-B599-00108A383D01}" type="slidenum">
               <a:t>&lt;#&gt;</a:t>
             </a:fld>
           </a:p>
@@ -1975,7 +1975,7 @@
         <p:txBody>
           <a:bodyPr/>
           <a:p>
-            <a:fld id="{E29187CA-A10C-4647-AB05-AC5FFB8908BE}" type="slidenum">
+            <a:fld id="{5E3E29FA-ED62-45F5-845F-E8ADAB5C29DA}" type="slidenum">
               <a:t>&lt;#&gt;</a:t>
             </a:fld>
           </a:p>
@@ -2186,7 +2186,7 @@
         <p:txBody>
           <a:bodyPr/>
           <a:p>
-            <a:fld id="{A29D8777-552D-4A63-A8E9-A37B9709E4D9}" type="slidenum">
+            <a:fld id="{8AB87A4D-2FBB-4A5C-8D5A-679F8F0183FA}" type="slidenum">
               <a:t>&lt;#&gt;</a:t>
             </a:fld>
           </a:p>
@@ -2354,7 +2354,7 @@
         <p:txBody>
           <a:bodyPr/>
           <a:p>
-            <a:fld id="{C438441B-A119-4F31-8054-8D71884C7A15}" type="slidenum">
+            <a:fld id="{91B3858F-3F30-4F70-8073-91F7E89CA7B1}" type="slidenum">
               <a:t>&lt;#&gt;</a:t>
             </a:fld>
           </a:p>
@@ -2608,7 +2608,7 @@
         <p:txBody>
           <a:bodyPr/>
           <a:p>
-            <a:fld id="{39731254-F2F5-4F2C-8DCC-6562F1F4B0B0}" type="slidenum">
+            <a:fld id="{25FD1CDB-8E58-44E6-9FEA-2E8FCA28FC63}" type="slidenum">
               <a:t>&lt;#&gt;</a:t>
             </a:fld>
           </a:p>
@@ -2948,7 +2948,7 @@
         <p:txBody>
           <a:bodyPr/>
           <a:p>
-            <a:fld id="{9C1E5494-628C-4560-AE17-3F0BFAC78B79}" type="slidenum">
+            <a:fld id="{06923133-6E16-47C0-9025-FA030EAE742C}" type="slidenum">
               <a:t>&lt;#&gt;</a:t>
             </a:fld>
           </a:p>
@@ -3073,7 +3073,7 @@
         <p:txBody>
           <a:bodyPr/>
           <a:p>
-            <a:fld id="{FFEDA4F6-A442-4271-9348-4C7C1B598B94}" type="slidenum">
+            <a:fld id="{3349030D-2063-4ECA-8A3B-30FBA2B98F88}" type="slidenum">
               <a:t>&lt;#&gt;</a:t>
             </a:fld>
           </a:p>
@@ -3241,7 +3241,7 @@
         <p:txBody>
           <a:bodyPr/>
           <a:p>
-            <a:fld id="{8879E04E-74F7-4801-A1F9-1EC52F617E05}" type="slidenum">
+            <a:fld id="{0CFCA9E5-D8F5-412C-8B63-71C9518C643E}" type="slidenum">
               <a:t>&lt;#&gt;</a:t>
             </a:fld>
           </a:p>
@@ -3323,7 +3323,7 @@
         <p:txBody>
           <a:bodyPr/>
           <a:p>
-            <a:fld id="{777AF825-8B10-4D54-8EF1-A484F3314A8D}" type="slidenum">
+            <a:fld id="{9E4B8DA3-FF32-4132-AD7D-7DAE37C905C9}" type="slidenum">
               <a:t>&lt;#&gt;</a:t>
             </a:fld>
           </a:p>
@@ -3403,7 +3403,7 @@
         <p:txBody>
           <a:bodyPr/>
           <a:p>
-            <a:fld id="{FF979D6C-1647-415C-A02F-B0B9A5177115}" type="slidenum">
+            <a:fld id="{238A5BCB-A0E2-453E-96FB-0B40453E3C2D}" type="slidenum">
               <a:t>&lt;#&gt;</a:t>
             </a:fld>
           </a:p>
@@ -3614,7 +3614,7 @@
         <p:txBody>
           <a:bodyPr/>
           <a:p>
-            <a:fld id="{A3B62A8F-BAE3-4509-8B66-01B11ECCC772}" type="slidenum">
+            <a:fld id="{AB8E8584-761E-4119-BD6B-740B578C85B0}" type="slidenum">
               <a:t>&lt;#&gt;</a:t>
             </a:fld>
           </a:p>
@@ -3825,7 +3825,7 @@
         <p:txBody>
           <a:bodyPr/>
           <a:p>
-            <a:fld id="{F0F5510B-9A89-440B-915C-75D940F8DEF6}" type="slidenum">
+            <a:fld id="{5093203B-A91D-4011-8A32-167B212DD8CE}" type="slidenum">
               <a:t>&lt;#&gt;</a:t>
             </a:fld>
           </a:p>
@@ -4036,7 +4036,7 @@
         <p:txBody>
           <a:bodyPr/>
           <a:p>
-            <a:fld id="{899FDE53-34AC-42E3-A0E8-18729DB6ED8C}" type="slidenum">
+            <a:fld id="{45B6E11D-50E7-4C92-B938-1388088C1ED1}" type="slidenum">
               <a:t>&lt;#&gt;</a:t>
             </a:fld>
           </a:p>
@@ -4127,13 +4127,238 @@
             <a:spLocks noGrp="1"/>
           </p:cNvSpPr>
           <p:nvPr>
+            <p:ph type="body"/>
+          </p:nvPr>
+        </p:nvSpPr>
+        <p:spPr>
+          <a:xfrm>
+            <a:off x="457200" y="1203480"/>
+            <a:ext cx="8228880" cy="2982600"/>
+          </a:xfrm>
+          <a:prstGeom prst="rect">
+            <a:avLst/>
+          </a:prstGeom>
+          <a:noFill/>
+          <a:ln w="0">
+            <a:noFill/>
+          </a:ln>
+        </p:spPr>
+        <p:txBody>
+          <a:bodyPr lIns="0" rIns="0" tIns="0" bIns="0" anchor="t">
+            <a:normAutofit/>
+          </a:bodyPr>
+          <a:p>
+            <a:pPr marL="432000" indent="-324000">
+              <a:spcBef>
+                <a:spcPts val="1417"/>
+              </a:spcBef>
+              <a:buClr>
+                <a:srgbClr val="000000"/>
+              </a:buClr>
+              <a:buSzPct val="45000"/>
+              <a:buFont typeface="Wingdings" charset="2"/>
+              <a:buChar char=""/>
+            </a:pPr>
+            <a:r>
+              <a:rPr b="0" lang="es-MX" sz="1800" spc="-1" strike="noStrike">
+                <a:solidFill>
+                  <a:srgbClr val="000000"/>
+                </a:solidFill>
+                <a:latin typeface="Arial"/>
+              </a:rPr>
+              <a:t>Pulse para editar el formato de texto del esquema</a:t>
+            </a:r>
+            <a:endParaRPr b="0" lang="es-MX" sz="1800" spc="-1" strike="noStrike">
+              <a:solidFill>
+                <a:srgbClr val="000000"/>
+              </a:solidFill>
+              <a:latin typeface="Arial"/>
+            </a:endParaRPr>
+          </a:p>
+          <a:p>
+            <a:pPr lvl="1" marL="864000" indent="-324000">
+              <a:spcBef>
+                <a:spcPts val="1134"/>
+              </a:spcBef>
+              <a:buClr>
+                <a:srgbClr val="000000"/>
+              </a:buClr>
+              <a:buSzPct val="75000"/>
+              <a:buFont typeface="Symbol" charset="2"/>
+              <a:buChar char=""/>
+            </a:pPr>
+            <a:r>
+              <a:rPr b="0" lang="es-MX" sz="1800" spc="-1" strike="noStrike">
+                <a:solidFill>
+                  <a:srgbClr val="000000"/>
+                </a:solidFill>
+                <a:latin typeface="Arial"/>
+              </a:rPr>
+              <a:t>Segundo nivel del esquema</a:t>
+            </a:r>
+            <a:endParaRPr b="0" lang="es-MX" sz="1800" spc="-1" strike="noStrike">
+              <a:solidFill>
+                <a:srgbClr val="000000"/>
+              </a:solidFill>
+              <a:latin typeface="Arial"/>
+            </a:endParaRPr>
+          </a:p>
+          <a:p>
+            <a:pPr lvl="2" marL="1296000" indent="-288000">
+              <a:spcBef>
+                <a:spcPts val="850"/>
+              </a:spcBef>
+              <a:buClr>
+                <a:srgbClr val="000000"/>
+              </a:buClr>
+              <a:buSzPct val="45000"/>
+              <a:buFont typeface="Wingdings" charset="2"/>
+              <a:buChar char=""/>
+            </a:pPr>
+            <a:r>
+              <a:rPr b="0" lang="es-MX" sz="1800" spc="-1" strike="noStrike">
+                <a:solidFill>
+                  <a:srgbClr val="000000"/>
+                </a:solidFill>
+                <a:latin typeface="Arial"/>
+              </a:rPr>
+              <a:t>Tercer nivel del esquema</a:t>
+            </a:r>
+            <a:endParaRPr b="0" lang="es-MX" sz="1800" spc="-1" strike="noStrike">
+              <a:solidFill>
+                <a:srgbClr val="000000"/>
+              </a:solidFill>
+              <a:latin typeface="Arial"/>
+            </a:endParaRPr>
+          </a:p>
+          <a:p>
+            <a:pPr lvl="3" marL="1728000" indent="-216000">
+              <a:spcBef>
+                <a:spcPts val="567"/>
+              </a:spcBef>
+              <a:buClr>
+                <a:srgbClr val="000000"/>
+              </a:buClr>
+              <a:buSzPct val="75000"/>
+              <a:buFont typeface="Symbol" charset="2"/>
+              <a:buChar char=""/>
+            </a:pPr>
+            <a:r>
+              <a:rPr b="0" lang="es-MX" sz="1800" spc="-1" strike="noStrike">
+                <a:solidFill>
+                  <a:srgbClr val="000000"/>
+                </a:solidFill>
+                <a:latin typeface="Arial"/>
+              </a:rPr>
+              <a:t>Cuarto nivel del esquema</a:t>
+            </a:r>
+            <a:endParaRPr b="0" lang="es-MX" sz="1800" spc="-1" strike="noStrike">
+              <a:solidFill>
+                <a:srgbClr val="000000"/>
+              </a:solidFill>
+              <a:latin typeface="Arial"/>
+            </a:endParaRPr>
+          </a:p>
+          <a:p>
+            <a:pPr lvl="4" marL="2160000" indent="-216000">
+              <a:spcBef>
+                <a:spcPts val="283"/>
+              </a:spcBef>
+              <a:buClr>
+                <a:srgbClr val="000000"/>
+              </a:buClr>
+              <a:buSzPct val="45000"/>
+              <a:buFont typeface="Wingdings" charset="2"/>
+              <a:buChar char=""/>
+            </a:pPr>
+            <a:r>
+              <a:rPr b="0" lang="es-MX" sz="1800" spc="-1" strike="noStrike">
+                <a:solidFill>
+                  <a:srgbClr val="000000"/>
+                </a:solidFill>
+                <a:latin typeface="Arial"/>
+              </a:rPr>
+              <a:t>Quinto nivel del esquema</a:t>
+            </a:r>
+            <a:endParaRPr b="0" lang="es-MX" sz="1800" spc="-1" strike="noStrike">
+              <a:solidFill>
+                <a:srgbClr val="000000"/>
+              </a:solidFill>
+              <a:latin typeface="Arial"/>
+            </a:endParaRPr>
+          </a:p>
+          <a:p>
+            <a:pPr lvl="5" marL="2592000" indent="-216000">
+              <a:spcBef>
+                <a:spcPts val="283"/>
+              </a:spcBef>
+              <a:buClr>
+                <a:srgbClr val="000000"/>
+              </a:buClr>
+              <a:buSzPct val="45000"/>
+              <a:buFont typeface="Wingdings" charset="2"/>
+              <a:buChar char=""/>
+            </a:pPr>
+            <a:r>
+              <a:rPr b="0" lang="es-MX" sz="1800" spc="-1" strike="noStrike">
+                <a:solidFill>
+                  <a:srgbClr val="000000"/>
+                </a:solidFill>
+                <a:latin typeface="Arial"/>
+              </a:rPr>
+              <a:t>Sexto nivel del esquema</a:t>
+            </a:r>
+            <a:endParaRPr b="0" lang="es-MX" sz="1800" spc="-1" strike="noStrike">
+              <a:solidFill>
+                <a:srgbClr val="000000"/>
+              </a:solidFill>
+              <a:latin typeface="Arial"/>
+            </a:endParaRPr>
+          </a:p>
+          <a:p>
+            <a:pPr lvl="6" marL="3024000" indent="-216000">
+              <a:spcBef>
+                <a:spcPts val="283"/>
+              </a:spcBef>
+              <a:buClr>
+                <a:srgbClr val="000000"/>
+              </a:buClr>
+              <a:buSzPct val="45000"/>
+              <a:buFont typeface="Wingdings" charset="2"/>
+              <a:buChar char=""/>
+            </a:pPr>
+            <a:r>
+              <a:rPr b="0" lang="es-MX" sz="1800" spc="-1" strike="noStrike">
+                <a:solidFill>
+                  <a:srgbClr val="000000"/>
+                </a:solidFill>
+                <a:latin typeface="Arial"/>
+              </a:rPr>
+              <a:t>Séptimo nivel del esquema</a:t>
+            </a:r>
+            <a:endParaRPr b="0" lang="es-MX" sz="1800" spc="-1" strike="noStrike">
+              <a:solidFill>
+                <a:srgbClr val="000000"/>
+              </a:solidFill>
+              <a:latin typeface="Arial"/>
+            </a:endParaRPr>
+          </a:p>
+        </p:txBody>
+      </p:sp>
+      <p:sp>
+        <p:nvSpPr>
+          <p:cNvPr id="2" name="PlaceHolder 3"/>
+          <p:cNvSpPr>
+            <a:spLocks noGrp="1"/>
+          </p:cNvSpPr>
+          <p:nvPr>
             <p:ph type="sldNum" idx="1"/>
           </p:nvPr>
         </p:nvSpPr>
         <p:spPr>
           <a:xfrm>
             <a:off x="8472600" y="4663080"/>
-            <a:ext cx="547920" cy="392760"/>
+            <a:ext cx="547560" cy="392400"/>
           </a:xfrm>
           <a:prstGeom prst="rect">
             <a:avLst/>
@@ -4175,7 +4400,7 @@
                 <a:tab algn="l" pos="0"/>
               </a:tabLst>
             </a:pPr>
-            <a:fld id="{6BDC99D6-452E-4B46-9C02-9848138B4BAA}" type="slidenum">
+            <a:fld id="{0F402E15-3FDD-4A45-88B1-E4567C4A232E}" type="slidenum">
               <a:rPr b="0" lang="en" sz="1000" spc="-1" strike="noStrike">
                 <a:solidFill>
                   <a:schemeClr val="dk2"/>
@@ -4183,238 +4408,13 @@
                 <a:latin typeface="Arial"/>
                 <a:ea typeface="Arial"/>
               </a:rPr>
-              <a:t>5</a:t>
+              <a:t>&lt;número&gt;</a:t>
             </a:fld>
             <a:endParaRPr b="0" lang="es-MX" sz="1000" spc="-1" strike="noStrike">
               <a:solidFill>
                 <a:srgbClr val="000000"/>
               </a:solidFill>
               <a:latin typeface="Times New Roman"/>
-            </a:endParaRPr>
-          </a:p>
-        </p:txBody>
-      </p:sp>
-      <p:sp>
-        <p:nvSpPr>
-          <p:cNvPr id="2" name="PlaceHolder 3"/>
-          <p:cNvSpPr>
-            <a:spLocks noGrp="1"/>
-          </p:cNvSpPr>
-          <p:nvPr>
-            <p:ph type="body"/>
-          </p:nvPr>
-        </p:nvSpPr>
-        <p:spPr>
-          <a:xfrm>
-            <a:off x="457200" y="1203480"/>
-            <a:ext cx="8229240" cy="2982960"/>
-          </a:xfrm>
-          <a:prstGeom prst="rect">
-            <a:avLst/>
-          </a:prstGeom>
-          <a:noFill/>
-          <a:ln w="0">
-            <a:noFill/>
-          </a:ln>
-        </p:spPr>
-        <p:txBody>
-          <a:bodyPr lIns="0" rIns="0" tIns="0" bIns="0" anchor="t">
-            <a:normAutofit fontScale="96000"/>
-          </a:bodyPr>
-          <a:p>
-            <a:pPr marL="414720" indent="-311040">
-              <a:spcBef>
-                <a:spcPts val="1417"/>
-              </a:spcBef>
-              <a:buClr>
-                <a:srgbClr val="000000"/>
-              </a:buClr>
-              <a:buSzPct val="45000"/>
-              <a:buFont typeface="Wingdings" charset="2"/>
-              <a:buChar char=""/>
-            </a:pPr>
-            <a:r>
-              <a:rPr b="0" lang="es-MX" sz="3200" spc="-1" strike="noStrike">
-                <a:solidFill>
-                  <a:srgbClr val="000000"/>
-                </a:solidFill>
-                <a:latin typeface="Arial"/>
-              </a:rPr>
-              <a:t>Pulse para editar el formato de texto del esquema</a:t>
-            </a:r>
-            <a:endParaRPr b="0" lang="es-MX" sz="3200" spc="-1" strike="noStrike">
-              <a:solidFill>
-                <a:srgbClr val="000000"/>
-              </a:solidFill>
-              <a:latin typeface="Arial"/>
-            </a:endParaRPr>
-          </a:p>
-          <a:p>
-            <a:pPr lvl="1" marL="829440" indent="-311040">
-              <a:spcBef>
-                <a:spcPts val="1134"/>
-              </a:spcBef>
-              <a:buClr>
-                <a:srgbClr val="000000"/>
-              </a:buClr>
-              <a:buSzPct val="75000"/>
-              <a:buFont typeface="Symbol" charset="2"/>
-              <a:buChar char=""/>
-            </a:pPr>
-            <a:r>
-              <a:rPr b="0" lang="es-MX" sz="2800" spc="-1" strike="noStrike">
-                <a:solidFill>
-                  <a:srgbClr val="000000"/>
-                </a:solidFill>
-                <a:latin typeface="Arial"/>
-              </a:rPr>
-              <a:t>Segundo nivel del esquema</a:t>
-            </a:r>
-            <a:endParaRPr b="0" lang="es-MX" sz="2800" spc="-1" strike="noStrike">
-              <a:solidFill>
-                <a:srgbClr val="000000"/>
-              </a:solidFill>
-              <a:latin typeface="Arial"/>
-            </a:endParaRPr>
-          </a:p>
-          <a:p>
-            <a:pPr lvl="2" marL="1244160" indent="-276480">
-              <a:spcBef>
-                <a:spcPts val="850"/>
-              </a:spcBef>
-              <a:buClr>
-                <a:srgbClr val="000000"/>
-              </a:buClr>
-              <a:buSzPct val="45000"/>
-              <a:buFont typeface="Wingdings" charset="2"/>
-              <a:buChar char=""/>
-            </a:pPr>
-            <a:r>
-              <a:rPr b="0" lang="es-MX" sz="2400" spc="-1" strike="noStrike">
-                <a:solidFill>
-                  <a:srgbClr val="000000"/>
-                </a:solidFill>
-                <a:latin typeface="Arial"/>
-              </a:rPr>
-              <a:t>Tercer nivel del esquema</a:t>
-            </a:r>
-            <a:endParaRPr b="0" lang="es-MX" sz="2400" spc="-1" strike="noStrike">
-              <a:solidFill>
-                <a:srgbClr val="000000"/>
-              </a:solidFill>
-              <a:latin typeface="Arial"/>
-            </a:endParaRPr>
-          </a:p>
-          <a:p>
-            <a:pPr lvl="3" marL="1658880" indent="-207360">
-              <a:spcBef>
-                <a:spcPts val="567"/>
-              </a:spcBef>
-              <a:buClr>
-                <a:srgbClr val="000000"/>
-              </a:buClr>
-              <a:buSzPct val="75000"/>
-              <a:buFont typeface="Symbol" charset="2"/>
-              <a:buChar char=""/>
-            </a:pPr>
-            <a:r>
-              <a:rPr b="0" lang="es-MX" sz="2000" spc="-1" strike="noStrike">
-                <a:solidFill>
-                  <a:srgbClr val="000000"/>
-                </a:solidFill>
-                <a:latin typeface="Arial"/>
-              </a:rPr>
-              <a:t>Cuarto nivel del esquema</a:t>
-            </a:r>
-            <a:endParaRPr b="0" lang="es-MX" sz="2000" spc="-1" strike="noStrike">
-              <a:solidFill>
-                <a:srgbClr val="000000"/>
-              </a:solidFill>
-              <a:latin typeface="Arial"/>
-            </a:endParaRPr>
-          </a:p>
-          <a:p>
-            <a:pPr lvl="4" marL="2073600" indent="-207360">
-              <a:spcBef>
-                <a:spcPts val="283"/>
-              </a:spcBef>
-              <a:buClr>
-                <a:srgbClr val="000000"/>
-              </a:buClr>
-              <a:buSzPct val="45000"/>
-              <a:buFont typeface="Wingdings" charset="2"/>
-              <a:buChar char=""/>
-            </a:pPr>
-            <a:r>
-              <a:rPr b="0" lang="es-MX" sz="2000" spc="-1" strike="noStrike">
-                <a:solidFill>
-                  <a:srgbClr val="000000"/>
-                </a:solidFill>
-                <a:latin typeface="Arial"/>
-              </a:rPr>
-              <a:t>Quinto nivel del esquema</a:t>
-            </a:r>
-            <a:endParaRPr b="0" lang="es-MX" sz="2000" spc="-1" strike="noStrike">
-              <a:solidFill>
-                <a:srgbClr val="000000"/>
-              </a:solidFill>
-              <a:latin typeface="Arial"/>
-            </a:endParaRPr>
-          </a:p>
-          <a:p>
-            <a:pPr lvl="5" marL="2488320" indent="-207360">
-              <a:spcBef>
-                <a:spcPts val="283"/>
-              </a:spcBef>
-              <a:buClr>
-                <a:srgbClr val="000000"/>
-              </a:buClr>
-              <a:buSzPct val="45000"/>
-              <a:buFont typeface="Wingdings" charset="2"/>
-              <a:buChar char=""/>
-            </a:pPr>
-            <a:r>
-              <a:rPr b="0" lang="es-MX" sz="2000" spc="-1" strike="noStrike">
-                <a:solidFill>
-                  <a:srgbClr val="000000"/>
-                </a:solidFill>
-                <a:latin typeface="Arial"/>
-              </a:rPr>
-              <a:t>Sexto nivel del esquema</a:t>
-            </a:r>
-            <a:endParaRPr b="0" lang="es-MX" sz="2000" spc="-1" strike="noStrike">
-              <a:solidFill>
-                <a:srgbClr val="000000"/>
-              </a:solidFill>
-              <a:latin typeface="Arial"/>
-            </a:endParaRPr>
-          </a:p>
-          <a:p>
-            <a:pPr lvl="6" marL="2903040" indent="-207360">
-              <a:spcBef>
-                <a:spcPts val="283"/>
-              </a:spcBef>
-              <a:buClr>
-                <a:srgbClr val="000000"/>
-              </a:buClr>
-              <a:buSzPct val="45000"/>
-              <a:buFont typeface="Wingdings" charset="2"/>
-              <a:buChar char=""/>
-            </a:pPr>
-            <a:r>
-              <a:rPr b="0" lang="es-MX" sz="2000" spc="-1" strike="noStrike">
-                <a:solidFill>
-                  <a:srgbClr val="000000"/>
-                </a:solidFill>
-                <a:latin typeface="Arial"/>
-              </a:rPr>
-              <a:t>Séptimo nivel del esquema</a:t>
-            </a:r>
-            <a:endParaRPr b="0" lang="es-MX" sz="2000" spc="-1" strike="noStrike">
-              <a:solidFill>
-                <a:srgbClr val="000000"/>
-              </a:solidFill>
-              <a:latin typeface="Arial"/>
             </a:endParaRPr>
           </a:p>
         </p:txBody>
@@ -4476,7 +4476,7 @@
         <p:spPr>
           <a:xfrm>
             <a:off x="8472600" y="4663080"/>
-            <a:ext cx="547920" cy="392760"/>
+            <a:ext cx="547560" cy="392400"/>
           </a:xfrm>
           <a:prstGeom prst="rect">
             <a:avLst/>
@@ -4518,7 +4518,7 @@
                 <a:tab algn="l" pos="0"/>
               </a:tabLst>
             </a:pPr>
-            <a:fld id="{33372394-D000-4583-BD92-A51E6D66AD67}" type="slidenum">
+            <a:fld id="{F55FB502-CA5F-47B8-BE1A-8C4148086876}" type="slidenum">
               <a:rPr b="0" lang="en" sz="1000" spc="-1" strike="noStrike">
                 <a:solidFill>
                   <a:schemeClr val="dk2"/>
@@ -4868,7 +4868,7 @@
         <p:spPr>
           <a:xfrm>
             <a:off x="64080" y="638280"/>
-            <a:ext cx="8519760" cy="2169360"/>
+            <a:ext cx="8519400" cy="2169000"/>
           </a:xfrm>
           <a:prstGeom prst="rect">
             <a:avLst/>
@@ -4954,7 +4954,7 @@
         <p:spPr>
           <a:xfrm>
             <a:off x="228600" y="228600"/>
-            <a:ext cx="866160" cy="193680"/>
+            <a:ext cx="865800" cy="193320"/>
           </a:xfrm>
           <a:prstGeom prst="rect">
             <a:avLst/>
@@ -4964,6 +4964,48 @@
           </a:ln>
         </p:spPr>
       </p:pic>
+      <p:sp>
+        <p:nvSpPr>
+          <p:cNvPr id="80" name=""/>
+          <p:cNvSpPr txBox="1"/>
+          <p:nvPr/>
+        </p:nvSpPr>
+        <p:spPr>
+          <a:xfrm>
+            <a:off x="144360" y="4612680"/>
+            <a:ext cx="1983600" cy="336600"/>
+          </a:xfrm>
+          <a:prstGeom prst="rect">
+            <a:avLst/>
+          </a:prstGeom>
+          <a:noFill/>
+          <a:ln w="0">
+            <a:noFill/>
+          </a:ln>
+        </p:spPr>
+        <p:txBody>
+          <a:bodyPr lIns="90000" rIns="90000" tIns="45000" bIns="45000" anchor="t">
+            <a:noAutofit/>
+          </a:bodyPr>
+          <a:p>
+            <a:fld id="{A07A1B4F-749E-4CB9-BBAB-8552EB07C1F2}" type="datetime5">
+              <a:rPr b="0" i="1" lang="es-MX" sz="1500" spc="-1" strike="noStrike">
+                <a:solidFill>
+                  <a:srgbClr val="000000"/>
+                </a:solidFill>
+                <a:latin typeface="Verdana"/>
+              </a:rPr>
+              <a:t>20 de ago de 2025</a:t>
+            </a:fld>
+            <a:endParaRPr b="0" lang="es-MX" sz="1500" spc="-1" strike="noStrike">
+              <a:solidFill>
+                <a:srgbClr val="000000"/>
+              </a:solidFill>
+              <a:latin typeface="Times New Roman"/>
+            </a:endParaRPr>
+          </a:p>
+        </p:txBody>
+      </p:sp>
     </p:spTree>
   </p:cSld>
   <mc:AlternateContent>
@@ -5003,7 +5045,7 @@
       </p:grpSpPr>
       <p:sp>
         <p:nvSpPr>
-          <p:cNvPr id="80" name="PlaceHolder 1"/>
+          <p:cNvPr id="81" name="PlaceHolder 1"/>
           <p:cNvSpPr>
             <a:spLocks noGrp="1"/>
           </p:cNvSpPr>
@@ -5014,7 +5056,7 @@
         <p:spPr>
           <a:xfrm>
             <a:off x="152280" y="2017800"/>
-            <a:ext cx="8519760" cy="2989080"/>
+            <a:ext cx="8519400" cy="2988720"/>
           </a:xfrm>
           <a:prstGeom prst="rect">
             <a:avLst/>
@@ -5055,7 +5097,7 @@
             </a:endParaRPr>
           </a:p>
           <a:p>
-            <a:pPr marL="457200" indent="-380880">
+            <a:pPr marL="475920" indent="-396720">
               <a:lnSpc>
                 <a:spcPct val="100000"/>
               </a:lnSpc>
@@ -5099,7 +5141,7 @@
       </p:sp>
       <p:pic>
         <p:nvPicPr>
-          <p:cNvPr id="81" name="Google Shape;49;p16" descr=""/>
+          <p:cNvPr id="82" name="Google Shape;49;p16" descr=""/>
           <p:cNvPicPr/>
           <p:nvPr/>
         </p:nvPicPr>
@@ -5110,7 +5152,7 @@
         <p:spPr>
           <a:xfrm>
             <a:off x="228600" y="228600"/>
-            <a:ext cx="866160" cy="193680"/>
+            <a:ext cx="865800" cy="193320"/>
           </a:xfrm>
           <a:prstGeom prst="rect">
             <a:avLst/>
@@ -5122,7 +5164,7 @@
       </p:pic>
       <p:sp>
         <p:nvSpPr>
-          <p:cNvPr id="82" name="PlaceHolder 2"/>
+          <p:cNvPr id="83" name="PlaceHolder 2"/>
           <p:cNvSpPr>
             <a:spLocks noGrp="1"/>
           </p:cNvSpPr>
@@ -5133,7 +5175,7 @@
         <p:spPr>
           <a:xfrm>
             <a:off x="96840" y="424800"/>
-            <a:ext cx="8519760" cy="1041480"/>
+            <a:ext cx="8519400" cy="1041120"/>
           </a:xfrm>
           <a:prstGeom prst="rect">
             <a:avLst/>
@@ -5215,14 +5257,14 @@
       </p:grpSpPr>
       <p:sp>
         <p:nvSpPr>
-          <p:cNvPr id="83" name="Google Shape;213;p33"/>
+          <p:cNvPr id="84" name="Google Shape;213;p33"/>
           <p:cNvSpPr/>
           <p:nvPr/>
         </p:nvSpPr>
         <p:spPr>
           <a:xfrm>
             <a:off x="228600" y="1952280"/>
-            <a:ext cx="2724120" cy="2961720"/>
+            <a:ext cx="2723760" cy="2961360"/>
           </a:xfrm>
           <a:prstGeom prst="roundRect">
             <a:avLst>
@@ -5276,14 +5318,14 @@
       </p:sp>
       <p:sp>
         <p:nvSpPr>
-          <p:cNvPr id="84" name="Google Shape;214;p33"/>
+          <p:cNvPr id="85" name="Google Shape;214;p33"/>
           <p:cNvSpPr/>
           <p:nvPr/>
         </p:nvSpPr>
         <p:spPr>
           <a:xfrm>
             <a:off x="3209400" y="1952280"/>
-            <a:ext cx="2724120" cy="2961720"/>
+            <a:ext cx="2723760" cy="2961360"/>
           </a:xfrm>
           <a:prstGeom prst="roundRect">
             <a:avLst>
@@ -5337,14 +5379,14 @@
       </p:sp>
       <p:sp>
         <p:nvSpPr>
-          <p:cNvPr id="85" name="Google Shape;215;p33"/>
+          <p:cNvPr id="86" name="Google Shape;215;p33"/>
           <p:cNvSpPr/>
           <p:nvPr/>
         </p:nvSpPr>
         <p:spPr>
           <a:xfrm>
             <a:off x="6190560" y="1952280"/>
-            <a:ext cx="2724120" cy="2961720"/>
+            <a:ext cx="2723760" cy="2961360"/>
           </a:xfrm>
           <a:prstGeom prst="roundRect">
             <a:avLst>
@@ -5398,7 +5440,7 @@
       </p:sp>
       <p:pic>
         <p:nvPicPr>
-          <p:cNvPr id="86" name="Google Shape;216;p33" descr=""/>
+          <p:cNvPr id="87" name="Google Shape;216;p33" descr=""/>
           <p:cNvPicPr/>
           <p:nvPr/>
         </p:nvPicPr>
@@ -5409,7 +5451,7 @@
         <p:spPr>
           <a:xfrm>
             <a:off x="228600" y="228600"/>
-            <a:ext cx="866160" cy="193680"/>
+            <a:ext cx="865800" cy="193320"/>
           </a:xfrm>
           <a:prstGeom prst="rect">
             <a:avLst/>
@@ -5421,7 +5463,7 @@
       </p:pic>
       <p:sp>
         <p:nvSpPr>
-          <p:cNvPr id="87" name="PlaceHolder 1"/>
+          <p:cNvPr id="88" name="PlaceHolder 1"/>
           <p:cNvSpPr>
             <a:spLocks noGrp="1"/>
           </p:cNvSpPr>
@@ -5432,7 +5474,7 @@
         <p:spPr>
           <a:xfrm>
             <a:off x="96840" y="424800"/>
-            <a:ext cx="8519760" cy="1041480"/>
+            <a:ext cx="8519400" cy="1041120"/>
           </a:xfrm>
           <a:prstGeom prst="rect">
             <a:avLst/>
@@ -5477,7 +5519,7 @@
       </p:sp>
       <p:pic>
         <p:nvPicPr>
-          <p:cNvPr id="88" name="Google Shape;218;p33" descr=""/>
+          <p:cNvPr id="89" name="Google Shape;218;p33" descr=""/>
           <p:cNvPicPr/>
           <p:nvPr/>
         </p:nvPicPr>
@@ -5488,7 +5530,7 @@
         <p:spPr>
           <a:xfrm>
             <a:off x="424800" y="2191320"/>
-            <a:ext cx="473760" cy="759960"/>
+            <a:ext cx="473400" cy="759600"/>
           </a:xfrm>
           <a:prstGeom prst="rect">
             <a:avLst/>
@@ -5500,7 +5542,7 @@
       </p:pic>
       <p:pic>
         <p:nvPicPr>
-          <p:cNvPr id="89" name="Google Shape;219;p33" descr=""/>
+          <p:cNvPr id="90" name="Google Shape;219;p33" descr=""/>
           <p:cNvPicPr/>
           <p:nvPr/>
         </p:nvPicPr>
@@ -5511,7 +5553,7 @@
         <p:spPr>
           <a:xfrm>
             <a:off x="3468960" y="2191320"/>
-            <a:ext cx="473760" cy="759960"/>
+            <a:ext cx="473400" cy="759600"/>
           </a:xfrm>
           <a:prstGeom prst="rect">
             <a:avLst/>
@@ -5523,7 +5565,7 @@
       </p:pic>
       <p:pic>
         <p:nvPicPr>
-          <p:cNvPr id="90" name="Google Shape;220;p33" descr=""/>
+          <p:cNvPr id="91" name="Google Shape;220;p33" descr=""/>
           <p:cNvPicPr/>
           <p:nvPr/>
         </p:nvPicPr>
@@ -5534,7 +5576,7 @@
         <p:spPr>
           <a:xfrm>
             <a:off x="6407280" y="2191320"/>
-            <a:ext cx="473760" cy="759960"/>
+            <a:ext cx="473400" cy="759600"/>
           </a:xfrm>
           <a:prstGeom prst="rect">
             <a:avLst/>
@@ -5583,7 +5625,7 @@
       </p:grpSpPr>
       <p:pic>
         <p:nvPicPr>
-          <p:cNvPr id="91" name="Google Shape;240;p36" descr=""/>
+          <p:cNvPr id="92" name="Google Shape;240;p36" descr=""/>
           <p:cNvPicPr/>
           <p:nvPr/>
         </p:nvPicPr>
@@ -5594,7 +5636,7 @@
         <p:spPr>
           <a:xfrm>
             <a:off x="228600" y="228600"/>
-            <a:ext cx="866160" cy="193680"/>
+            <a:ext cx="865800" cy="193320"/>
           </a:xfrm>
           <a:prstGeom prst="rect">
             <a:avLst/>
@@ -5606,7 +5648,7 @@
       </p:pic>
       <p:sp>
         <p:nvSpPr>
-          <p:cNvPr id="92" name="PlaceHolder 1"/>
+          <p:cNvPr id="93" name="PlaceHolder 1"/>
           <p:cNvSpPr>
             <a:spLocks noGrp="1"/>
           </p:cNvSpPr>
@@ -5617,7 +5659,7 @@
         <p:spPr>
           <a:xfrm>
             <a:off x="322920" y="817560"/>
-            <a:ext cx="6137640" cy="3474720"/>
+            <a:ext cx="6137280" cy="3474360"/>
           </a:xfrm>
           <a:prstGeom prst="rect">
             <a:avLst/>
@@ -5699,7 +5741,7 @@
       </p:grpSpPr>
       <p:sp>
         <p:nvSpPr>
-          <p:cNvPr id="93" name="PlaceHolder 1"/>
+          <p:cNvPr id="94" name="PlaceHolder 1"/>
           <p:cNvSpPr>
             <a:spLocks noGrp="1"/>
           </p:cNvSpPr>
@@ -5710,7 +5752,7 @@
         <p:spPr>
           <a:xfrm>
             <a:off x="96840" y="2386440"/>
-            <a:ext cx="8519760" cy="2527560"/>
+            <a:ext cx="8519400" cy="2527200"/>
           </a:xfrm>
           <a:prstGeom prst="rect">
             <a:avLst/>
@@ -5755,7 +5797,7 @@
       </p:sp>
       <p:pic>
         <p:nvPicPr>
-          <p:cNvPr id="94" name="Google Shape;235;p 1" descr=""/>
+          <p:cNvPr id="95" name="Google Shape;235;p 1" descr=""/>
           <p:cNvPicPr/>
           <p:nvPr/>
         </p:nvPicPr>
@@ -5766,7 +5808,7 @@
         <p:spPr>
           <a:xfrm>
             <a:off x="228600" y="228600"/>
-            <a:ext cx="867960" cy="191160"/>
+            <a:ext cx="867600" cy="190800"/>
           </a:xfrm>
           <a:prstGeom prst="rect">
             <a:avLst/>
@@ -5815,7 +5857,7 @@
       </p:grpSpPr>
       <p:pic>
         <p:nvPicPr>
-          <p:cNvPr id="95" name="Google Shape;240;p36" descr=""/>
+          <p:cNvPr id="96" name="Google Shape;240;p36" descr=""/>
           <p:cNvPicPr/>
           <p:nvPr/>
         </p:nvPicPr>
@@ -5826,7 +5868,7 @@
         <p:spPr>
           <a:xfrm>
             <a:off x="228600" y="228600"/>
-            <a:ext cx="866160" cy="193680"/>
+            <a:ext cx="865800" cy="193320"/>
           </a:xfrm>
           <a:prstGeom prst="rect">
             <a:avLst/>
@@ -5838,7 +5880,7 @@
       </p:pic>
       <p:sp>
         <p:nvSpPr>
-          <p:cNvPr id="96" name="PlaceHolder 1"/>
+          <p:cNvPr id="97" name="PlaceHolder 1"/>
           <p:cNvSpPr>
             <a:spLocks noGrp="1"/>
           </p:cNvSpPr>
@@ -5849,7 +5891,7 @@
         <p:spPr>
           <a:xfrm>
             <a:off x="322920" y="817560"/>
-            <a:ext cx="6137640" cy="2651760"/>
+            <a:ext cx="6137280" cy="2651400"/>
           </a:xfrm>
           <a:prstGeom prst="rect">
             <a:avLst/>
@@ -5931,7 +5973,7 @@
       </p:grpSpPr>
       <p:sp>
         <p:nvSpPr>
-          <p:cNvPr id="97" name="PlaceHolder 1"/>
+          <p:cNvPr id="98" name="PlaceHolder 1"/>
           <p:cNvSpPr>
             <a:spLocks noGrp="1"/>
           </p:cNvSpPr>
@@ -5942,7 +5984,7 @@
         <p:spPr>
           <a:xfrm>
             <a:off x="311760" y="1914120"/>
-            <a:ext cx="8519760" cy="1041480"/>
+            <a:ext cx="8519400" cy="1041120"/>
           </a:xfrm>
           <a:prstGeom prst="rect">
             <a:avLst/>
@@ -5987,7 +6029,7 @@
       </p:sp>
       <p:pic>
         <p:nvPicPr>
-          <p:cNvPr id="98" name="Google Shape;270;p39" descr=""/>
+          <p:cNvPr id="99" name="Google Shape;270;p39" descr=""/>
           <p:cNvPicPr/>
           <p:nvPr/>
         </p:nvPicPr>
@@ -5998,7 +6040,7 @@
         <p:spPr>
           <a:xfrm>
             <a:off x="3642120" y="2053080"/>
-            <a:ext cx="644760" cy="644400"/>
+            <a:ext cx="644400" cy="644040"/>
           </a:xfrm>
           <a:prstGeom prst="rect">
             <a:avLst/>
@@ -6010,7 +6052,7 @@
       </p:pic>
       <p:pic>
         <p:nvPicPr>
-          <p:cNvPr id="99" name="Google Shape;271;p39" descr=""/>
+          <p:cNvPr id="100" name="Google Shape;271;p39" descr=""/>
           <p:cNvPicPr/>
           <p:nvPr/>
         </p:nvPicPr>
@@ -6021,7 +6063,7 @@
         <p:spPr>
           <a:xfrm>
             <a:off x="4138560" y="228600"/>
-            <a:ext cx="866160" cy="193680"/>
+            <a:ext cx="865800" cy="193320"/>
           </a:xfrm>
           <a:prstGeom prst="rect">
             <a:avLst/>

</xml_diff>